<commit_message>
Add week5 image features experiment
</commit_message>
<xml_diff>
--- a/week5task/task07_cs231n_assignment1/results/week5_cs231n_assignment1_report.pptx
+++ b/week5task/task07_cs231n_assignment1/results/week5_cs231n_assignment1_report.pptx
@@ -1,26 +1,27 @@
 
 <file path=ppt/presentation.xml><?xml version="1.0" encoding="utf-8"?>
-<p:presentation xmlns:a="http://schemas.openxmlformats.org/drawingml/2006/main" xmlns:r="http://schemas.openxmlformats.org/officeDocument/2006/relationships" xmlns:p="http://schemas.openxmlformats.org/presentationml/2006/main" saveSubsetFonts="1" autoCompressPictures="0">
+<p:presentation xmlns:a="http://schemas.openxmlformats.org/drawingml/2006/main" xmlns:r="http://schemas.openxmlformats.org/officeDocument/2006/relationships" xmlns:p="http://schemas.openxmlformats.org/presentationml/2006/main" autoCompressPictures="0">
   <p:sldMasterIdLst>
     <p:sldMasterId id="2147483648" r:id="rId1"/>
   </p:sldMasterIdLst>
   <p:sldIdLst>
-    <p:sldId id="256" r:id="rId7"/>
-    <p:sldId id="257" r:id="rId8"/>
-    <p:sldId id="258" r:id="rId9"/>
-    <p:sldId id="259" r:id="rId10"/>
-    <p:sldId id="260" r:id="rId11"/>
-    <p:sldId id="261" r:id="rId12"/>
-    <p:sldId id="262" r:id="rId13"/>
-    <p:sldId id="263" r:id="rId14"/>
-    <p:sldId id="264" r:id="rId15"/>
-    <p:sldId id="265" r:id="rId16"/>
-    <p:sldId id="266" r:id="rId17"/>
-    <p:sldId id="267" r:id="rId18"/>
-    <p:sldId id="268" r:id="rId19"/>
-    <p:sldId id="269" r:id="rId20"/>
+    <p:sldId id="256" r:id="rId3"/>
+    <p:sldId id="258" r:id="rId4"/>
+    <p:sldId id="259" r:id="rId5"/>
+    <p:sldId id="260" r:id="rId6"/>
+    <p:sldId id="261" r:id="rId7"/>
+    <p:sldId id="262" r:id="rId8"/>
+    <p:sldId id="263" r:id="rId9"/>
+    <p:sldId id="264" r:id="rId10"/>
+    <p:sldId id="265" r:id="rId11"/>
+    <p:sldId id="266" r:id="rId12"/>
+    <p:sldId id="267" r:id="rId13"/>
+    <p:sldId id="268" r:id="rId14"/>
+    <p:sldId id="269" r:id="rId18"/>
+    <p:sldId id="270" r:id="rId19"/>
+    <p:sldId id="271" r:id="rId20"/>
   </p:sldIdLst>
-  <p:sldSz cx="12191695" cy="6858000" type="screen4x3"/>
+  <p:sldSz cx="12191365" cy="6858000" type="screen4x3"/>
   <p:notesSz cx="6858000" cy="9144000"/>
   <p:defaultTextStyle>
     <a:defPPr>
@@ -117,6 +118,22 @@
       </a:defRPr>
     </a:lvl9pPr>
   </p:defaultTextStyle>
+  <p:extLst>
+    <p:ext uri="{EFAFB233-063F-42B5-8137-9DF3F51BA10A}">
+      <p15:sldGuideLst xmlns:p15="http://schemas.microsoft.com/office/powerpoint/2012/main">
+        <p15:guide id="1" orient="horz" pos="2160" userDrawn="1">
+          <p15:clr>
+            <a:srgbClr val="A4A3A4"/>
+          </p15:clr>
+        </p15:guide>
+        <p15:guide id="2" pos="2880" userDrawn="1">
+          <p15:clr>
+            <a:srgbClr val="A4A3A4"/>
+          </p15:clr>
+        </p15:guide>
+      </p15:sldGuideLst>
+    </p:ext>
+  </p:extLst>
 </p:presentation>
 </file>
 
@@ -301,7 +318,6 @@
           <a:p>
             <a:fld id="{5BCAD085-E8A6-8845-BD4E-CB4CCA059FC4}" type="datetimeFigureOut">
               <a:rPr lang="en-US" smtClean="0"/>
-              <a:t>1/27/13</a:t>
             </a:fld>
             <a:endParaRPr lang="en-US"/>
           </a:p>
@@ -343,18 +359,12 @@
           <a:p>
             <a:fld id="{C1FF6DA9-008F-8B48-92A6-B652298478BF}" type="slidenum">
               <a:rPr lang="en-US" smtClean="0"/>
-              <a:t>‹#›</a:t>
             </a:fld>
             <a:endParaRPr lang="en-US"/>
           </a:p>
         </p:txBody>
       </p:sp>
     </p:spTree>
-    <p:extLst>
-      <p:ext uri="{BB962C8B-B14F-4D97-AF65-F5344CB8AC3E}">
-        <p14:creationId xmlns:p14="http://schemas.microsoft.com/office/powerpoint/2010/main" val="3168075583"/>
-      </p:ext>
-    </p:extLst>
   </p:cSld>
   <p:clrMapOvr>
     <a:masterClrMapping/>
@@ -422,6 +432,7 @@
               <a:rPr lang="en-US" smtClean="0"/>
               <a:t>Click to edit Master text styles</a:t>
             </a:r>
+            <a:endParaRPr lang="en-US" smtClean="0"/>
           </a:p>
           <a:p>
             <a:pPr lvl="1"/>
@@ -429,6 +440,7 @@
               <a:rPr lang="en-US" smtClean="0"/>
               <a:t>Second level</a:t>
             </a:r>
+            <a:endParaRPr lang="en-US" smtClean="0"/>
           </a:p>
           <a:p>
             <a:pPr lvl="2"/>
@@ -436,6 +448,7 @@
               <a:rPr lang="en-US" smtClean="0"/>
               <a:t>Third level</a:t>
             </a:r>
+            <a:endParaRPr lang="en-US" smtClean="0"/>
           </a:p>
           <a:p>
             <a:pPr lvl="3"/>
@@ -443,6 +456,7 @@
               <a:rPr lang="en-US" smtClean="0"/>
               <a:t>Fourth level</a:t>
             </a:r>
+            <a:endParaRPr lang="en-US" smtClean="0"/>
           </a:p>
           <a:p>
             <a:pPr lvl="4"/>
@@ -471,7 +485,6 @@
           <a:p>
             <a:fld id="{5BCAD085-E8A6-8845-BD4E-CB4CCA059FC4}" type="datetimeFigureOut">
               <a:rPr lang="en-US" smtClean="0"/>
-              <a:t>1/27/13</a:t>
             </a:fld>
             <a:endParaRPr lang="en-US"/>
           </a:p>
@@ -513,18 +526,12 @@
           <a:p>
             <a:fld id="{C1FF6DA9-008F-8B48-92A6-B652298478BF}" type="slidenum">
               <a:rPr lang="en-US" smtClean="0"/>
-              <a:t>‹#›</a:t>
             </a:fld>
             <a:endParaRPr lang="en-US"/>
           </a:p>
         </p:txBody>
       </p:sp>
     </p:spTree>
-    <p:extLst>
-      <p:ext uri="{BB962C8B-B14F-4D97-AF65-F5344CB8AC3E}">
-        <p14:creationId xmlns:p14="http://schemas.microsoft.com/office/powerpoint/2010/main" val="2910927964"/>
-      </p:ext>
-    </p:extLst>
   </p:cSld>
   <p:clrMapOvr>
     <a:masterClrMapping/>
@@ -602,6 +609,7 @@
               <a:rPr lang="en-US" smtClean="0"/>
               <a:t>Click to edit Master text styles</a:t>
             </a:r>
+            <a:endParaRPr lang="en-US" smtClean="0"/>
           </a:p>
           <a:p>
             <a:pPr lvl="1"/>
@@ -609,6 +617,7 @@
               <a:rPr lang="en-US" smtClean="0"/>
               <a:t>Second level</a:t>
             </a:r>
+            <a:endParaRPr lang="en-US" smtClean="0"/>
           </a:p>
           <a:p>
             <a:pPr lvl="2"/>
@@ -616,6 +625,7 @@
               <a:rPr lang="en-US" smtClean="0"/>
               <a:t>Third level</a:t>
             </a:r>
+            <a:endParaRPr lang="en-US" smtClean="0"/>
           </a:p>
           <a:p>
             <a:pPr lvl="3"/>
@@ -623,6 +633,7 @@
               <a:rPr lang="en-US" smtClean="0"/>
               <a:t>Fourth level</a:t>
             </a:r>
+            <a:endParaRPr lang="en-US" smtClean="0"/>
           </a:p>
           <a:p>
             <a:pPr lvl="4"/>
@@ -651,7 +662,6 @@
           <a:p>
             <a:fld id="{5BCAD085-E8A6-8845-BD4E-CB4CCA059FC4}" type="datetimeFigureOut">
               <a:rPr lang="en-US" smtClean="0"/>
-              <a:t>1/27/13</a:t>
             </a:fld>
             <a:endParaRPr lang="en-US"/>
           </a:p>
@@ -693,18 +703,12 @@
           <a:p>
             <a:fld id="{C1FF6DA9-008F-8B48-92A6-B652298478BF}" type="slidenum">
               <a:rPr lang="en-US" smtClean="0"/>
-              <a:t>‹#›</a:t>
             </a:fld>
             <a:endParaRPr lang="en-US"/>
           </a:p>
         </p:txBody>
       </p:sp>
     </p:spTree>
-    <p:extLst>
-      <p:ext uri="{BB962C8B-B14F-4D97-AF65-F5344CB8AC3E}">
-        <p14:creationId xmlns:p14="http://schemas.microsoft.com/office/powerpoint/2010/main" val="3612223792"/>
-      </p:ext>
-    </p:extLst>
   </p:cSld>
   <p:clrMapOvr>
     <a:masterClrMapping/>
@@ -772,6 +776,7 @@
               <a:rPr lang="en-US" smtClean="0"/>
               <a:t>Click to edit Master text styles</a:t>
             </a:r>
+            <a:endParaRPr lang="en-US" smtClean="0"/>
           </a:p>
           <a:p>
             <a:pPr lvl="1"/>
@@ -779,6 +784,7 @@
               <a:rPr lang="en-US" smtClean="0"/>
               <a:t>Second level</a:t>
             </a:r>
+            <a:endParaRPr lang="en-US" smtClean="0"/>
           </a:p>
           <a:p>
             <a:pPr lvl="2"/>
@@ -786,6 +792,7 @@
               <a:rPr lang="en-US" smtClean="0"/>
               <a:t>Third level</a:t>
             </a:r>
+            <a:endParaRPr lang="en-US" smtClean="0"/>
           </a:p>
           <a:p>
             <a:pPr lvl="3"/>
@@ -793,6 +800,7 @@
               <a:rPr lang="en-US" smtClean="0"/>
               <a:t>Fourth level</a:t>
             </a:r>
+            <a:endParaRPr lang="en-US" smtClean="0"/>
           </a:p>
           <a:p>
             <a:pPr lvl="4"/>
@@ -821,7 +829,6 @@
           <a:p>
             <a:fld id="{5BCAD085-E8A6-8845-BD4E-CB4CCA059FC4}" type="datetimeFigureOut">
               <a:rPr lang="en-US" smtClean="0"/>
-              <a:t>1/27/13</a:t>
             </a:fld>
             <a:endParaRPr lang="en-US"/>
           </a:p>
@@ -863,18 +870,12 @@
           <a:p>
             <a:fld id="{C1FF6DA9-008F-8B48-92A6-B652298478BF}" type="slidenum">
               <a:rPr lang="en-US" smtClean="0"/>
-              <a:t>‹#›</a:t>
             </a:fld>
             <a:endParaRPr lang="en-US"/>
           </a:p>
         </p:txBody>
       </p:sp>
     </p:spTree>
-    <p:extLst>
-      <p:ext uri="{BB962C8B-B14F-4D97-AF65-F5344CB8AC3E}">
-        <p14:creationId xmlns:p14="http://schemas.microsoft.com/office/powerpoint/2010/main" val="2614314258"/>
-      </p:ext>
-    </p:extLst>
   </p:cSld>
   <p:clrMapOvr>
     <a:masterClrMapping/>
@@ -1047,6 +1048,7 @@
               <a:rPr lang="en-US" smtClean="0"/>
               <a:t>Click to edit Master text styles</a:t>
             </a:r>
+            <a:endParaRPr lang="en-US" smtClean="0"/>
           </a:p>
         </p:txBody>
       </p:sp>
@@ -1067,7 +1069,6 @@
           <a:p>
             <a:fld id="{5BCAD085-E8A6-8845-BD4E-CB4CCA059FC4}" type="datetimeFigureOut">
               <a:rPr lang="en-US" smtClean="0"/>
-              <a:t>1/27/13</a:t>
             </a:fld>
             <a:endParaRPr lang="en-US"/>
           </a:p>
@@ -1109,18 +1110,12 @@
           <a:p>
             <a:fld id="{C1FF6DA9-008F-8B48-92A6-B652298478BF}" type="slidenum">
               <a:rPr lang="en-US" smtClean="0"/>
-              <a:t>‹#›</a:t>
             </a:fld>
             <a:endParaRPr lang="en-US"/>
           </a:p>
         </p:txBody>
       </p:sp>
     </p:spTree>
-    <p:extLst>
-      <p:ext uri="{BB962C8B-B14F-4D97-AF65-F5344CB8AC3E}">
-        <p14:creationId xmlns:p14="http://schemas.microsoft.com/office/powerpoint/2010/main" val="960648375"/>
-      </p:ext>
-    </p:extLst>
   </p:cSld>
   <p:clrMapOvr>
     <a:masterClrMapping/>
@@ -1221,6 +1216,7 @@
               <a:rPr lang="en-US" smtClean="0"/>
               <a:t>Click to edit Master text styles</a:t>
             </a:r>
+            <a:endParaRPr lang="en-US" smtClean="0"/>
           </a:p>
           <a:p>
             <a:pPr lvl="1"/>
@@ -1228,6 +1224,7 @@
               <a:rPr lang="en-US" smtClean="0"/>
               <a:t>Second level</a:t>
             </a:r>
+            <a:endParaRPr lang="en-US" smtClean="0"/>
           </a:p>
           <a:p>
             <a:pPr lvl="2"/>
@@ -1235,6 +1232,7 @@
               <a:rPr lang="en-US" smtClean="0"/>
               <a:t>Third level</a:t>
             </a:r>
+            <a:endParaRPr lang="en-US" smtClean="0"/>
           </a:p>
           <a:p>
             <a:pPr lvl="3"/>
@@ -1242,6 +1240,7 @@
               <a:rPr lang="en-US" smtClean="0"/>
               <a:t>Fourth level</a:t>
             </a:r>
+            <a:endParaRPr lang="en-US" smtClean="0"/>
           </a:p>
           <a:p>
             <a:pPr lvl="4"/>
@@ -1306,6 +1305,7 @@
               <a:rPr lang="en-US" smtClean="0"/>
               <a:t>Click to edit Master text styles</a:t>
             </a:r>
+            <a:endParaRPr lang="en-US" smtClean="0"/>
           </a:p>
           <a:p>
             <a:pPr lvl="1"/>
@@ -1313,6 +1313,7 @@
               <a:rPr lang="en-US" smtClean="0"/>
               <a:t>Second level</a:t>
             </a:r>
+            <a:endParaRPr lang="en-US" smtClean="0"/>
           </a:p>
           <a:p>
             <a:pPr lvl="2"/>
@@ -1320,6 +1321,7 @@
               <a:rPr lang="en-US" smtClean="0"/>
               <a:t>Third level</a:t>
             </a:r>
+            <a:endParaRPr lang="en-US" smtClean="0"/>
           </a:p>
           <a:p>
             <a:pPr lvl="3"/>
@@ -1327,6 +1329,7 @@
               <a:rPr lang="en-US" smtClean="0"/>
               <a:t>Fourth level</a:t>
             </a:r>
+            <a:endParaRPr lang="en-US" smtClean="0"/>
           </a:p>
           <a:p>
             <a:pPr lvl="4"/>
@@ -1355,7 +1358,6 @@
           <a:p>
             <a:fld id="{5BCAD085-E8A6-8845-BD4E-CB4CCA059FC4}" type="datetimeFigureOut">
               <a:rPr lang="en-US" smtClean="0"/>
-              <a:t>1/27/13</a:t>
             </a:fld>
             <a:endParaRPr lang="en-US"/>
           </a:p>
@@ -1397,18 +1399,12 @@
           <a:p>
             <a:fld id="{C1FF6DA9-008F-8B48-92A6-B652298478BF}" type="slidenum">
               <a:rPr lang="en-US" smtClean="0"/>
-              <a:t>‹#›</a:t>
             </a:fld>
             <a:endParaRPr lang="en-US"/>
           </a:p>
         </p:txBody>
       </p:sp>
     </p:spTree>
-    <p:extLst>
-      <p:ext uri="{BB962C8B-B14F-4D97-AF65-F5344CB8AC3E}">
-        <p14:creationId xmlns:p14="http://schemas.microsoft.com/office/powerpoint/2010/main" val="2782244947"/>
-      </p:ext>
-    </p:extLst>
   </p:cSld>
   <p:clrMapOvr>
     <a:masterClrMapping/>
@@ -1522,6 +1518,7 @@
               <a:rPr lang="en-US" smtClean="0"/>
               <a:t>Click to edit Master text styles</a:t>
             </a:r>
+            <a:endParaRPr lang="en-US" smtClean="0"/>
           </a:p>
         </p:txBody>
       </p:sp>
@@ -1578,6 +1575,7 @@
               <a:rPr lang="en-US" smtClean="0"/>
               <a:t>Click to edit Master text styles</a:t>
             </a:r>
+            <a:endParaRPr lang="en-US" smtClean="0"/>
           </a:p>
           <a:p>
             <a:pPr lvl="1"/>
@@ -1585,6 +1583,7 @@
               <a:rPr lang="en-US" smtClean="0"/>
               <a:t>Second level</a:t>
             </a:r>
+            <a:endParaRPr lang="en-US" smtClean="0"/>
           </a:p>
           <a:p>
             <a:pPr lvl="2"/>
@@ -1592,6 +1591,7 @@
               <a:rPr lang="en-US" smtClean="0"/>
               <a:t>Third level</a:t>
             </a:r>
+            <a:endParaRPr lang="en-US" smtClean="0"/>
           </a:p>
           <a:p>
             <a:pPr lvl="3"/>
@@ -1599,6 +1599,7 @@
               <a:rPr lang="en-US" smtClean="0"/>
               <a:t>Fourth level</a:t>
             </a:r>
+            <a:endParaRPr lang="en-US" smtClean="0"/>
           </a:p>
           <a:p>
             <a:pPr lvl="4"/>
@@ -1672,6 +1673,7 @@
               <a:rPr lang="en-US" smtClean="0"/>
               <a:t>Click to edit Master text styles</a:t>
             </a:r>
+            <a:endParaRPr lang="en-US" smtClean="0"/>
           </a:p>
         </p:txBody>
       </p:sp>
@@ -1728,6 +1730,7 @@
               <a:rPr lang="en-US" smtClean="0"/>
               <a:t>Click to edit Master text styles</a:t>
             </a:r>
+            <a:endParaRPr lang="en-US" smtClean="0"/>
           </a:p>
           <a:p>
             <a:pPr lvl="1"/>
@@ -1735,6 +1738,7 @@
               <a:rPr lang="en-US" smtClean="0"/>
               <a:t>Second level</a:t>
             </a:r>
+            <a:endParaRPr lang="en-US" smtClean="0"/>
           </a:p>
           <a:p>
             <a:pPr lvl="2"/>
@@ -1742,6 +1746,7 @@
               <a:rPr lang="en-US" smtClean="0"/>
               <a:t>Third level</a:t>
             </a:r>
+            <a:endParaRPr lang="en-US" smtClean="0"/>
           </a:p>
           <a:p>
             <a:pPr lvl="3"/>
@@ -1749,6 +1754,7 @@
               <a:rPr lang="en-US" smtClean="0"/>
               <a:t>Fourth level</a:t>
             </a:r>
+            <a:endParaRPr lang="en-US" smtClean="0"/>
           </a:p>
           <a:p>
             <a:pPr lvl="4"/>
@@ -1777,7 +1783,6 @@
           <a:p>
             <a:fld id="{5BCAD085-E8A6-8845-BD4E-CB4CCA059FC4}" type="datetimeFigureOut">
               <a:rPr lang="en-US" smtClean="0"/>
-              <a:t>1/27/13</a:t>
             </a:fld>
             <a:endParaRPr lang="en-US"/>
           </a:p>
@@ -1819,18 +1824,12 @@
           <a:p>
             <a:fld id="{C1FF6DA9-008F-8B48-92A6-B652298478BF}" type="slidenum">
               <a:rPr lang="en-US" smtClean="0"/>
-              <a:t>‹#›</a:t>
             </a:fld>
             <a:endParaRPr lang="en-US"/>
           </a:p>
         </p:txBody>
       </p:sp>
     </p:spTree>
-    <p:extLst>
-      <p:ext uri="{BB962C8B-B14F-4D97-AF65-F5344CB8AC3E}">
-        <p14:creationId xmlns:p14="http://schemas.microsoft.com/office/powerpoint/2010/main" val="990158736"/>
-      </p:ext>
-    </p:extLst>
   </p:cSld>
   <p:clrMapOvr>
     <a:masterClrMapping/>
@@ -1895,7 +1894,6 @@
           <a:p>
             <a:fld id="{5BCAD085-E8A6-8845-BD4E-CB4CCA059FC4}" type="datetimeFigureOut">
               <a:rPr lang="en-US" smtClean="0"/>
-              <a:t>1/27/13</a:t>
             </a:fld>
             <a:endParaRPr lang="en-US"/>
           </a:p>
@@ -1937,18 +1935,12 @@
           <a:p>
             <a:fld id="{C1FF6DA9-008F-8B48-92A6-B652298478BF}" type="slidenum">
               <a:rPr lang="en-US" smtClean="0"/>
-              <a:t>‹#›</a:t>
             </a:fld>
             <a:endParaRPr lang="en-US"/>
           </a:p>
         </p:txBody>
       </p:sp>
     </p:spTree>
-    <p:extLst>
-      <p:ext uri="{BB962C8B-B14F-4D97-AF65-F5344CB8AC3E}">
-        <p14:creationId xmlns:p14="http://schemas.microsoft.com/office/powerpoint/2010/main" val="727027711"/>
-      </p:ext>
-    </p:extLst>
   </p:cSld>
   <p:clrMapOvr>
     <a:masterClrMapping/>
@@ -1990,7 +1982,6 @@
           <a:p>
             <a:fld id="{5BCAD085-E8A6-8845-BD4E-CB4CCA059FC4}" type="datetimeFigureOut">
               <a:rPr lang="en-US" smtClean="0"/>
-              <a:t>1/27/13</a:t>
             </a:fld>
             <a:endParaRPr lang="en-US"/>
           </a:p>
@@ -2032,18 +2023,12 @@
           <a:p>
             <a:fld id="{C1FF6DA9-008F-8B48-92A6-B652298478BF}" type="slidenum">
               <a:rPr lang="en-US" smtClean="0"/>
-              <a:t>‹#›</a:t>
             </a:fld>
             <a:endParaRPr lang="en-US"/>
           </a:p>
         </p:txBody>
       </p:sp>
     </p:spTree>
-    <p:extLst>
-      <p:ext uri="{BB962C8B-B14F-4D97-AF65-F5344CB8AC3E}">
-        <p14:creationId xmlns:p14="http://schemas.microsoft.com/office/powerpoint/2010/main" val="1212999818"/>
-      </p:ext>
-    </p:extLst>
   </p:cSld>
   <p:clrMapOvr>
     <a:masterClrMapping/>
@@ -2153,6 +2138,7 @@
               <a:rPr lang="en-US" smtClean="0"/>
               <a:t>Click to edit Master text styles</a:t>
             </a:r>
+            <a:endParaRPr lang="en-US" smtClean="0"/>
           </a:p>
           <a:p>
             <a:pPr lvl="1"/>
@@ -2160,6 +2146,7 @@
               <a:rPr lang="en-US" smtClean="0"/>
               <a:t>Second level</a:t>
             </a:r>
+            <a:endParaRPr lang="en-US" smtClean="0"/>
           </a:p>
           <a:p>
             <a:pPr lvl="2"/>
@@ -2167,6 +2154,7 @@
               <a:rPr lang="en-US" smtClean="0"/>
               <a:t>Third level</a:t>
             </a:r>
+            <a:endParaRPr lang="en-US" smtClean="0"/>
           </a:p>
           <a:p>
             <a:pPr lvl="3"/>
@@ -2174,6 +2162,7 @@
               <a:rPr lang="en-US" smtClean="0"/>
               <a:t>Fourth level</a:t>
             </a:r>
+            <a:endParaRPr lang="en-US" smtClean="0"/>
           </a:p>
           <a:p>
             <a:pPr lvl="4"/>
@@ -2247,6 +2236,7 @@
               <a:rPr lang="en-US" smtClean="0"/>
               <a:t>Click to edit Master text styles</a:t>
             </a:r>
+            <a:endParaRPr lang="en-US" smtClean="0"/>
           </a:p>
         </p:txBody>
       </p:sp>
@@ -2267,7 +2257,6 @@
           <a:p>
             <a:fld id="{5BCAD085-E8A6-8845-BD4E-CB4CCA059FC4}" type="datetimeFigureOut">
               <a:rPr lang="en-US" smtClean="0"/>
-              <a:t>1/27/13</a:t>
             </a:fld>
             <a:endParaRPr lang="en-US"/>
           </a:p>
@@ -2309,18 +2298,12 @@
           <a:p>
             <a:fld id="{C1FF6DA9-008F-8B48-92A6-B652298478BF}" type="slidenum">
               <a:rPr lang="en-US" smtClean="0"/>
-              <a:t>‹#›</a:t>
             </a:fld>
             <a:endParaRPr lang="en-US"/>
           </a:p>
         </p:txBody>
       </p:sp>
     </p:spTree>
-    <p:extLst>
-      <p:ext uri="{BB962C8B-B14F-4D97-AF65-F5344CB8AC3E}">
-        <p14:creationId xmlns:p14="http://schemas.microsoft.com/office/powerpoint/2010/main" val="1840726560"/>
-      </p:ext>
-    </p:extLst>
   </p:cSld>
   <p:clrMapOvr>
     <a:masterClrMapping/>
@@ -2500,6 +2483,7 @@
               <a:rPr lang="en-US" smtClean="0"/>
               <a:t>Click to edit Master text styles</a:t>
             </a:r>
+            <a:endParaRPr lang="en-US" smtClean="0"/>
           </a:p>
         </p:txBody>
       </p:sp>
@@ -2520,7 +2504,6 @@
           <a:p>
             <a:fld id="{5BCAD085-E8A6-8845-BD4E-CB4CCA059FC4}" type="datetimeFigureOut">
               <a:rPr lang="en-US" smtClean="0"/>
-              <a:t>1/27/13</a:t>
             </a:fld>
             <a:endParaRPr lang="en-US"/>
           </a:p>
@@ -2562,18 +2545,12 @@
           <a:p>
             <a:fld id="{C1FF6DA9-008F-8B48-92A6-B652298478BF}" type="slidenum">
               <a:rPr lang="en-US" smtClean="0"/>
-              <a:t>‹#›</a:t>
             </a:fld>
             <a:endParaRPr lang="en-US"/>
           </a:p>
         </p:txBody>
       </p:sp>
     </p:spTree>
-    <p:extLst>
-      <p:ext uri="{BB962C8B-B14F-4D97-AF65-F5344CB8AC3E}">
-        <p14:creationId xmlns:p14="http://schemas.microsoft.com/office/powerpoint/2010/main" val="3889236939"/>
-      </p:ext>
-    </p:extLst>
   </p:cSld>
   <p:clrMapOvr>
     <a:masterClrMapping/>
@@ -2666,6 +2643,7 @@
               <a:rPr lang="en-US" smtClean="0"/>
               <a:t>Click to edit Master text styles</a:t>
             </a:r>
+            <a:endParaRPr lang="en-US" smtClean="0"/>
           </a:p>
           <a:p>
             <a:pPr lvl="1"/>
@@ -2673,6 +2651,7 @@
               <a:rPr lang="en-US" smtClean="0"/>
               <a:t>Second level</a:t>
             </a:r>
+            <a:endParaRPr lang="en-US" smtClean="0"/>
           </a:p>
           <a:p>
             <a:pPr lvl="2"/>
@@ -2680,6 +2659,7 @@
               <a:rPr lang="en-US" smtClean="0"/>
               <a:t>Third level</a:t>
             </a:r>
+            <a:endParaRPr lang="en-US" smtClean="0"/>
           </a:p>
           <a:p>
             <a:pPr lvl="3"/>
@@ -2687,6 +2667,7 @@
               <a:rPr lang="en-US" smtClean="0"/>
               <a:t>Fourth level</a:t>
             </a:r>
+            <a:endParaRPr lang="en-US" smtClean="0"/>
           </a:p>
           <a:p>
             <a:pPr lvl="4"/>
@@ -2733,7 +2714,6 @@
           <a:p>
             <a:fld id="{5BCAD085-E8A6-8845-BD4E-CB4CCA059FC4}" type="datetimeFigureOut">
               <a:rPr lang="en-US" smtClean="0"/>
-              <a:t>1/27/13</a:t>
             </a:fld>
             <a:endParaRPr lang="en-US"/>
           </a:p>
@@ -2811,18 +2791,12 @@
           <a:p>
             <a:fld id="{C1FF6DA9-008F-8B48-92A6-B652298478BF}" type="slidenum">
               <a:rPr lang="en-US" smtClean="0"/>
-              <a:t>‹#›</a:t>
             </a:fld>
             <a:endParaRPr lang="en-US"/>
           </a:p>
         </p:txBody>
       </p:sp>
     </p:spTree>
-    <p:extLst>
-      <p:ext uri="{BB962C8B-B14F-4D97-AF65-F5344CB8AC3E}">
-        <p14:creationId xmlns:p14="http://schemas.microsoft.com/office/powerpoint/2010/main" val="2209977519"/>
-      </p:ext>
-    </p:extLst>
   </p:cSld>
   <p:clrMap bg1="lt1" tx1="dk1" bg2="lt2" tx2="dk2" accent1="accent1" accent2="accent2" accent3="accent3" accent4="accent4" accent5="accent5" accent6="accent6" hlink="hlink" folHlink="folHlink"/>
   <p:sldLayoutIdLst>
@@ -2860,7 +2834,7 @@
         <a:spcBef>
           <a:spcPct val="20000"/>
         </a:spcBef>
-        <a:buFont typeface="Arial"/>
+        <a:buFont typeface="Arial" panose="020B0604020202020204"/>
         <a:buChar char="•"/>
         <a:defRPr sz="3200" kern="1200">
           <a:solidFill>
@@ -2875,7 +2849,7 @@
         <a:spcBef>
           <a:spcPct val="20000"/>
         </a:spcBef>
-        <a:buFont typeface="Arial"/>
+        <a:buFont typeface="Arial" panose="020B0604020202020204"/>
         <a:buChar char="–"/>
         <a:defRPr sz="2800" kern="1200">
           <a:solidFill>
@@ -2890,7 +2864,7 @@
         <a:spcBef>
           <a:spcPct val="20000"/>
         </a:spcBef>
-        <a:buFont typeface="Arial"/>
+        <a:buFont typeface="Arial" panose="020B0604020202020204"/>
         <a:buChar char="•"/>
         <a:defRPr sz="2400" kern="1200">
           <a:solidFill>
@@ -2905,7 +2879,7 @@
         <a:spcBef>
           <a:spcPct val="20000"/>
         </a:spcBef>
-        <a:buFont typeface="Arial"/>
+        <a:buFont typeface="Arial" panose="020B0604020202020204"/>
         <a:buChar char="–"/>
         <a:defRPr sz="2000" kern="1200">
           <a:solidFill>
@@ -2920,7 +2894,7 @@
         <a:spcBef>
           <a:spcPct val="20000"/>
         </a:spcBef>
-        <a:buFont typeface="Arial"/>
+        <a:buFont typeface="Arial" panose="020B0604020202020204"/>
         <a:buChar char="»"/>
         <a:defRPr sz="2000" kern="1200">
           <a:solidFill>
@@ -2935,7 +2909,7 @@
         <a:spcBef>
           <a:spcPct val="20000"/>
         </a:spcBef>
-        <a:buFont typeface="Arial"/>
+        <a:buFont typeface="Arial" panose="020B0604020202020204"/>
         <a:buChar char="•"/>
         <a:defRPr sz="2000" kern="1200">
           <a:solidFill>
@@ -2950,7 +2924,7 @@
         <a:spcBef>
           <a:spcPct val="20000"/>
         </a:spcBef>
-        <a:buFont typeface="Arial"/>
+        <a:buFont typeface="Arial" panose="020B0604020202020204"/>
         <a:buChar char="•"/>
         <a:defRPr sz="2000" kern="1200">
           <a:solidFill>
@@ -2965,7 +2939,7 @@
         <a:spcBef>
           <a:spcPct val="20000"/>
         </a:spcBef>
-        <a:buFont typeface="Arial"/>
+        <a:buFont typeface="Arial" panose="020B0604020202020204"/>
         <a:buChar char="•"/>
         <a:defRPr sz="2000" kern="1200">
           <a:solidFill>
@@ -2980,7 +2954,7 @@
         <a:spcBef>
           <a:spcPct val="20000"/>
         </a:spcBef>
-        <a:buFont typeface="Arial"/>
+        <a:buFont typeface="Arial" panose="020B0604020202020204"/>
         <a:buChar char="•"/>
         <a:defRPr sz="2000" kern="1200">
           <a:solidFill>
@@ -3092,7 +3066,7 @@
 </file>
 
 <file path=ppt/slides/slide1.xml><?xml version="1.0" encoding="utf-8"?>
-<p:sld xmlns:a="http://schemas.openxmlformats.org/drawingml/2006/main" xmlns:p="http://schemas.openxmlformats.org/presentationml/2006/main" xmlns:r="http://schemas.openxmlformats.org/officeDocument/2006/relationships">
+<p:sld xmlns:a="http://schemas.openxmlformats.org/drawingml/2006/main" xmlns:r="http://schemas.openxmlformats.org/officeDocument/2006/relationships" xmlns:p="http://schemas.openxmlformats.org/presentationml/2006/main">
   <p:cSld>
     <p:bg>
       <p:bgPr>
@@ -3136,10 +3110,16 @@
                 <a:solidFill>
                   <a:srgbClr val="2A2E34"/>
                 </a:solidFill>
-                <a:latin typeface="Microsoft YaHei"/>
+                <a:latin typeface="微软雅黑" panose="020B0503020204020204" charset="-122"/>
               </a:rPr>
               <a:t>Week5 CS231n Assignment 1</a:t>
             </a:r>
+            <a:endParaRPr sz="3400" b="1">
+              <a:solidFill>
+                <a:srgbClr val="2A2E34"/>
+              </a:solidFill>
+              <a:latin typeface="微软雅黑" panose="020B0503020204020204" charset="-122"/>
+            </a:endParaRPr>
           </a:p>
         </p:txBody>
       </p:sp>
@@ -3170,10 +3150,16 @@
                 <a:solidFill>
                   <a:srgbClr val="2A2E34"/>
                 </a:solidFill>
-                <a:latin typeface="Microsoft YaHei"/>
+                <a:latin typeface="微软雅黑" panose="020B0503020204020204" charset="-122"/>
               </a:rPr>
               <a:t>CIFAR-10 图像分类本地复现实验：kNN、Softmax、TwoLayerNet</a:t>
             </a:r>
+            <a:endParaRPr sz="1800" b="0">
+              <a:solidFill>
+                <a:srgbClr val="2A2E34"/>
+              </a:solidFill>
+              <a:latin typeface="微软雅黑" panose="020B0503020204020204" charset="-122"/>
+            </a:endParaRPr>
           </a:p>
         </p:txBody>
       </p:sp>
@@ -3204,10 +3190,16 @@
                 <a:solidFill>
                   <a:srgbClr val="4F8968"/>
                 </a:solidFill>
-                <a:latin typeface="Microsoft YaHei"/>
+                <a:latin typeface="微软雅黑" panose="020B0503020204020204" charset="-122"/>
               </a:rPr>
               <a:t>最佳测试准确率：TwoLayerNet / N49000 / 0.493</a:t>
             </a:r>
+            <a:endParaRPr sz="2000" b="1">
+              <a:solidFill>
+                <a:srgbClr val="4F8968"/>
+              </a:solidFill>
+              <a:latin typeface="微软雅黑" panose="020B0503020204020204" charset="-122"/>
+            </a:endParaRPr>
           </a:p>
         </p:txBody>
       </p:sp>
@@ -3238,10 +3230,88 @@
                 <a:solidFill>
                   <a:srgbClr val="2A2E34"/>
                 </a:solidFill>
-                <a:latin typeface="Microsoft YaHei"/>
+                <a:latin typeface="微软雅黑" panose="020B0503020204020204" charset="-122"/>
               </a:rPr>
               <a:t>数据规模：10k / 20k / 49k 训练样本；验证与测试各 1k</a:t>
             </a:r>
+            <a:endParaRPr sz="1500" b="0">
+              <a:solidFill>
+                <a:srgbClr val="2A2E34"/>
+              </a:solidFill>
+              <a:latin typeface="微软雅黑" panose="020B0503020204020204" charset="-122"/>
+            </a:endParaRPr>
+          </a:p>
+        </p:txBody>
+      </p:sp>
+      <p:sp>
+        <p:nvSpPr>
+          <p:cNvPr id="6" name="TextBox 3"/>
+          <p:cNvSpPr txBox="1"/>
+          <p:nvPr/>
+        </p:nvSpPr>
+        <p:spPr>
+          <a:xfrm>
+            <a:off x="658495" y="3931920"/>
+            <a:ext cx="7809230" cy="1383665"/>
+          </a:xfrm>
+          <a:prstGeom prst="rect">
+            <a:avLst/>
+          </a:prstGeom>
+          <a:noFill/>
+        </p:spPr>
+        <p:txBody>
+          <a:bodyPr wrap="none">
+            <a:spAutoFit/>
+          </a:bodyPr>
+          <a:lstStyle/>
+          <a:p>
+            <a:pPr>
+              <a:spcAft>
+                <a:spcPts val="800"/>
+              </a:spcAft>
+              <a:defRPr sz="1600">
+                <a:latin typeface="微软雅黑" panose="020B0503020204020204" charset="-122"/>
+              </a:defRPr>
+            </a:pPr>
+            <a:r>
+              <a:t>CS231n A1 关注图像分类的完整工程链路</a:t>
+            </a:r>
+          </a:p>
+          <a:p>
+            <a:pPr>
+              <a:spcAft>
+                <a:spcPts val="800"/>
+              </a:spcAft>
+              <a:defRPr sz="1600">
+                <a:latin typeface="微软雅黑" panose="020B0503020204020204" charset="-122"/>
+              </a:defRPr>
+            </a:pPr>
+            <a:r>
+              <a:t>从 kNN 到 Softmax，再到两层神经网络</a:t>
+            </a:r>
+          </a:p>
+          <a:p>
+            <a:pPr>
+              <a:spcAft>
+                <a:spcPts val="800"/>
+              </a:spcAft>
+              <a:defRPr sz="1600">
+                <a:latin typeface="微软雅黑" panose="020B0503020204020204" charset="-122"/>
+              </a:defRPr>
+            </a:pPr>
+            <a:r>
+              <a:t>核心学习点：数据划分、loss、gradient、regularization、hyperparameter tuning</a:t>
+            </a:r>
+          </a:p>
+          <a:p>
+            <a:pPr>
+              <a:spcAft>
+                <a:spcPts val="800"/>
+              </a:spcAft>
+              <a:defRPr sz="1600">
+                <a:latin typeface="微软雅黑" panose="020B0503020204020204" charset="-122"/>
+              </a:defRPr>
+            </a:pPr>
           </a:p>
         </p:txBody>
       </p:sp>
@@ -3254,7 +3324,7 @@
 </file>
 
 <file path=ppt/slides/slide10.xml><?xml version="1.0" encoding="utf-8"?>
-<p:sld xmlns:a="http://schemas.openxmlformats.org/drawingml/2006/main" xmlns:p="http://schemas.openxmlformats.org/presentationml/2006/main" xmlns:r="http://schemas.openxmlformats.org/officeDocument/2006/relationships">
+<p:sld xmlns:a="http://schemas.openxmlformats.org/drawingml/2006/main" xmlns:r="http://schemas.openxmlformats.org/officeDocument/2006/relationships" xmlns:p="http://schemas.openxmlformats.org/presentationml/2006/main">
   <p:cSld>
     <p:bg>
       <p:bgPr>
@@ -3298,10 +3368,16 @@
                 <a:solidFill>
                   <a:srgbClr val="5F6F82"/>
                 </a:solidFill>
-                <a:latin typeface="Microsoft YaHei"/>
+                <a:latin typeface="微软雅黑" panose="020B0503020204020204" charset="-122"/>
               </a:rPr>
-              <a:t>DIAGNOSTICS</a:t>
-            </a:r>
+              <a:t>BEST MODEL</a:t>
+            </a:r>
+            <a:endParaRPr sz="900" b="1">
+              <a:solidFill>
+                <a:srgbClr val="5F6F82"/>
+              </a:solidFill>
+              <a:latin typeface="微软雅黑" panose="020B0503020204020204" charset="-122"/>
+            </a:endParaRPr>
           </a:p>
         </p:txBody>
       </p:sp>
@@ -3332,61 +3408,94 @@
                 <a:solidFill>
                   <a:srgbClr val="1E2328"/>
                 </a:solidFill>
-                <a:latin typeface="Microsoft YaHei"/>
+                <a:latin typeface="微软雅黑" panose="020B0503020204020204" charset="-122"/>
               </a:rPr>
-              <a:t>诊断图：loss 下降与类别混淆</a:t>
-            </a:r>
-          </a:p>
-        </p:txBody>
-      </p:sp>
-      <p:pic>
-        <p:nvPicPr>
-          <p:cNvPr id="4" name="Picture 3" descr="two_layer_loss_curve.png"/>
-          <p:cNvPicPr>
-            <a:picLocks noChangeAspect="1"/>
-          </p:cNvPicPr>
+              <a:t>最佳模型：TwoLayerNet 是本轮复现的主结果</a:t>
+            </a:r>
+            <a:endParaRPr sz="2400" b="1">
+              <a:solidFill>
+                <a:srgbClr val="1E2328"/>
+              </a:solidFill>
+              <a:latin typeface="微软雅黑" panose="020B0503020204020204" charset="-122"/>
+            </a:endParaRPr>
+          </a:p>
+        </p:txBody>
+      </p:sp>
+      <p:sp>
+        <p:nvSpPr>
+          <p:cNvPr id="4" name="TextBox 3"/>
+          <p:cNvSpPr txBox="1"/>
           <p:nvPr/>
-        </p:nvPicPr>
-        <p:blipFill>
-          <a:blip r:embed="rId2"/>
-          <a:stretch>
-            <a:fillRect/>
-          </a:stretch>
-        </p:blipFill>
-        <p:spPr>
-          <a:xfrm>
-            <a:off x="685800" y="1051560"/>
-            <a:ext cx="5120640" cy="2971800"/>
+        </p:nvSpPr>
+        <p:spPr>
+          <a:xfrm>
+            <a:off x="685800" y="1234440"/>
+            <a:ext cx="10424160" cy="4389120"/>
           </a:xfrm>
           <a:prstGeom prst="rect">
             <a:avLst/>
           </a:prstGeom>
-        </p:spPr>
-      </p:pic>
-      <p:pic>
-        <p:nvPicPr>
-          <p:cNvPr id="5" name="Picture 4" descr="confusion_matrix_best_model.png"/>
-          <p:cNvPicPr>
-            <a:picLocks noChangeAspect="1"/>
-          </p:cNvPicPr>
-          <p:nvPr/>
-        </p:nvPicPr>
-        <p:blipFill>
-          <a:blip r:embed="rId3"/>
-          <a:stretch>
-            <a:fillRect/>
-          </a:stretch>
-        </p:blipFill>
-        <p:spPr>
-          <a:xfrm>
-            <a:off x="6126480" y="914400"/>
-            <a:ext cx="5029200" cy="4297680"/>
-          </a:xfrm>
-          <a:prstGeom prst="rect">
-            <a:avLst/>
-          </a:prstGeom>
-        </p:spPr>
-      </p:pic>
+          <a:noFill/>
+        </p:spPr>
+        <p:txBody>
+          <a:bodyPr wrap="none">
+            <a:spAutoFit/>
+          </a:bodyPr>
+          <a:lstStyle/>
+          <a:p>
+            <a:pPr>
+              <a:spcAft>
+                <a:spcPts val="800"/>
+              </a:spcAft>
+              <a:defRPr sz="1600">
+                <a:latin typeface="微软雅黑" panose="020B0503020204020204" charset="-122"/>
+              </a:defRPr>
+            </a:pPr>
+            <a:r>
+              <a:t>按 validation：N49000 TwoLayerNet cfg4，val=0.515, test=0.493</a:t>
+            </a:r>
+          </a:p>
+          <a:p>
+            <a:pPr>
+              <a:spcAft>
+                <a:spcPts val="800"/>
+              </a:spcAft>
+              <a:defRPr sz="1600">
+                <a:latin typeface="微软雅黑" panose="020B0503020204020204" charset="-122"/>
+              </a:defRPr>
+            </a:pPr>
+            <a:r>
+              <a:t>按 test：部分配置测试准确率可到 0.510，但应以验证集选模</a:t>
+            </a:r>
+          </a:p>
+          <a:p>
+            <a:pPr>
+              <a:spcAft>
+                <a:spcPts val="800"/>
+              </a:spcAft>
+              <a:defRPr sz="1600">
+                <a:latin typeface="微软雅黑" panose="020B0503020204020204" charset="-122"/>
+              </a:defRPr>
+            </a:pPr>
+            <a:r>
+              <a:t>Softmax 最佳 test=0.359</a:t>
+            </a:r>
+          </a:p>
+          <a:p>
+            <a:pPr>
+              <a:spcAft>
+                <a:spcPts val="800"/>
+              </a:spcAft>
+              <a:defRPr sz="1600">
+                <a:latin typeface="微软雅黑" panose="020B0503020204020204" charset="-122"/>
+              </a:defRPr>
+            </a:pPr>
+            <a:r>
+              <a:t>kNN 最佳 test=0.348</a:t>
+            </a:r>
+          </a:p>
+        </p:txBody>
+      </p:sp>
     </p:spTree>
   </p:cSld>
   <p:clrMapOvr>
@@ -3396,7 +3505,7 @@
 </file>
 
 <file path=ppt/slides/slide11.xml><?xml version="1.0" encoding="utf-8"?>
-<p:sld xmlns:a="http://schemas.openxmlformats.org/drawingml/2006/main" xmlns:p="http://schemas.openxmlformats.org/presentationml/2006/main" xmlns:r="http://schemas.openxmlformats.org/officeDocument/2006/relationships">
+<p:sld xmlns:a="http://schemas.openxmlformats.org/drawingml/2006/main" xmlns:r="http://schemas.openxmlformats.org/officeDocument/2006/relationships" xmlns:p="http://schemas.openxmlformats.org/presentationml/2006/main">
   <p:cSld>
     <p:bg>
       <p:bgPr>
@@ -3440,10 +3549,16 @@
                 <a:solidFill>
                   <a:srgbClr val="5F6F82"/>
                 </a:solidFill>
-                <a:latin typeface="Microsoft YaHei"/>
+                <a:latin typeface="微软雅黑" panose="020B0503020204020204" charset="-122"/>
               </a:rPr>
-              <a:t>BEST MODEL</a:t>
-            </a:r>
+              <a:t>TAKEAWAYS</a:t>
+            </a:r>
+            <a:endParaRPr sz="900" b="1">
+              <a:solidFill>
+                <a:srgbClr val="5F6F82"/>
+              </a:solidFill>
+              <a:latin typeface="微软雅黑" panose="020B0503020204020204" charset="-122"/>
+            </a:endParaRPr>
           </a:p>
         </p:txBody>
       </p:sp>
@@ -3474,10 +3589,16 @@
                 <a:solidFill>
                   <a:srgbClr val="1E2328"/>
                 </a:solidFill>
-                <a:latin typeface="Microsoft YaHei"/>
+                <a:latin typeface="微软雅黑" panose="020B0503020204020204" charset="-122"/>
               </a:rPr>
-              <a:t>最佳模型：TwoLayerNet 是本轮复现的主结果</a:t>
-            </a:r>
+              <a:t>关键学习收获</a:t>
+            </a:r>
+            <a:endParaRPr sz="2400" b="1">
+              <a:solidFill>
+                <a:srgbClr val="1E2328"/>
+              </a:solidFill>
+              <a:latin typeface="微软雅黑" panose="020B0503020204020204" charset="-122"/>
+            </a:endParaRPr>
           </a:p>
         </p:txBody>
       </p:sp>
@@ -3508,11 +3629,11 @@
                 <a:spcPts val="800"/>
               </a:spcAft>
               <a:defRPr sz="1600">
-                <a:latin typeface="Microsoft YaHei"/>
+                <a:latin typeface="微软雅黑" panose="020B0503020204020204" charset="-122"/>
               </a:defRPr>
             </a:pPr>
             <a:r>
-              <a:t>按 validation：N49000 TwoLayerNet cfg4，val=0.515, test=0.493</a:t>
+              <a:t>图像分类 pipeline 的核心是数据划分 + 训练 + 验证调参 + 测试评估</a:t>
             </a:r>
           </a:p>
           <a:p>
@@ -3521,11 +3642,11 @@
                 <a:spcPts val="800"/>
               </a:spcAft>
               <a:defRPr sz="1600">
-                <a:latin typeface="Microsoft YaHei"/>
+                <a:latin typeface="微软雅黑" panose="020B0503020204020204" charset="-122"/>
               </a:defRPr>
             </a:pPr>
             <a:r>
-              <a:t>按 test：部分配置测试准确率可到 0.510，但应以验证集选模</a:t>
+              <a:t>向量化 NumPy 实现决定了实验能否高效运行</a:t>
             </a:r>
           </a:p>
           <a:p>
@@ -3534,11 +3655,11 @@
                 <a:spcPts val="800"/>
               </a:spcAft>
               <a:defRPr sz="1600">
-                <a:latin typeface="Microsoft YaHei"/>
+                <a:latin typeface="微软雅黑" panose="020B0503020204020204" charset="-122"/>
               </a:defRPr>
             </a:pPr>
             <a:r>
-              <a:t>Softmax 最佳 test=0.359</a:t>
+              <a:t>正则化和学习率会直接决定泛化性能</a:t>
             </a:r>
           </a:p>
           <a:p>
@@ -3547,11 +3668,24 @@
                 <a:spcPts val="800"/>
               </a:spcAft>
               <a:defRPr sz="1600">
-                <a:latin typeface="Microsoft YaHei"/>
+                <a:latin typeface="微软雅黑" panose="020B0503020204020204" charset="-122"/>
               </a:defRPr>
             </a:pPr>
             <a:r>
-              <a:t>kNN 最佳 test=0.348</a:t>
+              <a:t>raw pixels 能跑通流程，但不是好的视觉表示</a:t>
+            </a:r>
+          </a:p>
+          <a:p>
+            <a:pPr>
+              <a:spcAft>
+                <a:spcPts val="800"/>
+              </a:spcAft>
+              <a:defRPr sz="1600">
+                <a:latin typeface="微软雅黑" panose="020B0503020204020204" charset="-122"/>
+              </a:defRPr>
+            </a:pPr>
+            <a:r>
+              <a:t>非线性模型明显优于线性模型，但还不是 CNN</a:t>
             </a:r>
           </a:p>
         </p:txBody>
@@ -3565,7 +3699,7 @@
 </file>
 
 <file path=ppt/slides/slide12.xml><?xml version="1.0" encoding="utf-8"?>
-<p:sld xmlns:a="http://schemas.openxmlformats.org/drawingml/2006/main" xmlns:p="http://schemas.openxmlformats.org/presentationml/2006/main" xmlns:r="http://schemas.openxmlformats.org/officeDocument/2006/relationships">
+<p:sld xmlns:a="http://schemas.openxmlformats.org/drawingml/2006/main" xmlns:r="http://schemas.openxmlformats.org/officeDocument/2006/relationships" xmlns:p="http://schemas.openxmlformats.org/presentationml/2006/main">
   <p:cSld>
     <p:bg>
       <p:bgPr>
@@ -3609,10 +3743,16 @@
                 <a:solidFill>
                   <a:srgbClr val="5F6F82"/>
                 </a:solidFill>
-                <a:latin typeface="Microsoft YaHei"/>
+                <a:latin typeface="微软雅黑" panose="020B0503020204020204" charset="-122"/>
               </a:rPr>
-              <a:t>TAKEAWAYS</a:t>
-            </a:r>
+              <a:t>LIMITS</a:t>
+            </a:r>
+            <a:endParaRPr sz="900" b="1">
+              <a:solidFill>
+                <a:srgbClr val="5F6F82"/>
+              </a:solidFill>
+              <a:latin typeface="微软雅黑" panose="020B0503020204020204" charset="-122"/>
+            </a:endParaRPr>
           </a:p>
         </p:txBody>
       </p:sp>
@@ -3625,7 +3765,7 @@
         <p:spPr>
           <a:xfrm>
             <a:off x="502920" y="502920"/>
-            <a:ext cx="10424160" cy="502920"/>
+            <a:ext cx="9230995" cy="460375"/>
           </a:xfrm>
           <a:prstGeom prst="rect">
             <a:avLst/>
@@ -3643,10 +3783,52 @@
                 <a:solidFill>
                   <a:srgbClr val="1E2328"/>
                 </a:solidFill>
-                <a:latin typeface="Microsoft YaHei"/>
+                <a:latin typeface="微软雅黑" panose="020B0503020204020204" charset="-122"/>
               </a:rPr>
-              <a:t>关键学习收获</a:t>
-            </a:r>
+              <a:t>当前局限：还没有进入真正强的图像表示</a:t>
+            </a:r>
+            <a:r>
+              <a:rPr lang="zh-CN" sz="2400" b="1">
+                <a:solidFill>
+                  <a:srgbClr val="1E2328"/>
+                </a:solidFill>
+                <a:latin typeface="微软雅黑" panose="020B0503020204020204" charset="-122"/>
+              </a:rPr>
+              <a:t>（</a:t>
+            </a:r>
+            <a:r>
+              <a:rPr lang="en-US" altLang="zh-CN" sz="2400" b="1">
+                <a:solidFill>
+                  <a:srgbClr val="1E2328"/>
+                </a:solidFill>
+                <a:latin typeface="微软雅黑" panose="020B0503020204020204" charset="-122"/>
+              </a:rPr>
+              <a:t>ASSIGNMENT2</a:t>
+            </a:r>
+            <a:r>
+              <a:rPr lang="zh-CN" altLang="en-US" sz="2400" b="1">
+                <a:solidFill>
+                  <a:srgbClr val="1E2328"/>
+                </a:solidFill>
+                <a:latin typeface="微软雅黑" panose="020B0503020204020204" charset="-122"/>
+              </a:rPr>
+              <a:t>作业</a:t>
+            </a:r>
+            <a:r>
+              <a:rPr lang="zh-CN" sz="2400" b="1">
+                <a:solidFill>
+                  <a:srgbClr val="1E2328"/>
+                </a:solidFill>
+                <a:latin typeface="微软雅黑" panose="020B0503020204020204" charset="-122"/>
+              </a:rPr>
+              <a:t>）</a:t>
+            </a:r>
+            <a:endParaRPr lang="zh-CN" sz="2400" b="1">
+              <a:solidFill>
+                <a:srgbClr val="1E2328"/>
+              </a:solidFill>
+              <a:latin typeface="微软雅黑" panose="020B0503020204020204" charset="-122"/>
+            </a:endParaRPr>
           </a:p>
         </p:txBody>
       </p:sp>
@@ -3677,11 +3859,11 @@
                 <a:spcPts val="800"/>
               </a:spcAft>
               <a:defRPr sz="1600">
-                <a:latin typeface="Microsoft YaHei"/>
+                <a:latin typeface="微软雅黑" panose="020B0503020204020204" charset="-122"/>
               </a:defRPr>
             </a:pPr>
             <a:r>
-              <a:t>图像分类 pipeline 的核心是数据划分 + 训练 + 验证调参 + 测试评估</a:t>
+              <a:t>已补跑 HOG / color histogram features</a:t>
             </a:r>
           </a:p>
           <a:p>
@@ -3690,11 +3872,11 @@
                 <a:spcPts val="800"/>
               </a:spcAft>
               <a:defRPr sz="1600">
-                <a:latin typeface="Microsoft YaHei"/>
+                <a:latin typeface="微软雅黑" panose="020B0503020204020204" charset="-122"/>
               </a:defRPr>
             </a:pPr>
             <a:r>
-              <a:t>向量化 NumPy 实现决定了实验能否高效运行</a:t>
+              <a:t>FullyConnectedNet 的 dropout / batch normalization 还未展开</a:t>
             </a:r>
           </a:p>
           <a:p>
@@ -3703,11 +3885,11 @@
                 <a:spcPts val="800"/>
               </a:spcAft>
               <a:defRPr sz="1600">
-                <a:latin typeface="Microsoft YaHei"/>
+                <a:latin typeface="微软雅黑" panose="020B0503020204020204" charset="-122"/>
               </a:defRPr>
             </a:pPr>
             <a:r>
-              <a:t>正则化和学习率会直接决定泛化性能</a:t>
+              <a:t>测试集使用 1,000 张快速评估，后续可扩到完整 10,000 张</a:t>
             </a:r>
           </a:p>
           <a:p>
@@ -3716,25 +3898,150 @@
                 <a:spcPts val="800"/>
               </a:spcAft>
               <a:defRPr sz="1600">
-                <a:latin typeface="Microsoft YaHei"/>
+                <a:latin typeface="微软雅黑" panose="020B0503020204020204" charset="-122"/>
               </a:defRPr>
             </a:pPr>
             <a:r>
-              <a:t>raw pixels 能跑通流程，但不是好的视觉表示</a:t>
-            </a:r>
-          </a:p>
+              <a:t>未使用 CNN，因此没有利用图像局部空间结构</a:t>
+            </a:r>
+          </a:p>
+        </p:txBody>
+      </p:sp>
+      <p:sp>
+        <p:nvSpPr>
+          <p:cNvPr id="5" name="文本框 4"/>
+          <p:cNvSpPr txBox="1"/>
+          <p:nvPr/>
+        </p:nvSpPr>
+        <p:spPr>
+          <a:xfrm>
+            <a:off x="685800" y="3804285"/>
+            <a:ext cx="6096000" cy="1630045"/>
+          </a:xfrm>
+          <a:prstGeom prst="rect">
+            <a:avLst/>
+          </a:prstGeom>
+          <a:noFill/>
+        </p:spPr>
+        <p:txBody>
+          <a:bodyPr wrap="square" rtlCol="0" anchor="t">
+            <a:spAutoFit/>
+          </a:bodyPr>
           <a:p>
             <a:pPr>
               <a:spcAft>
                 <a:spcPts val="800"/>
               </a:spcAft>
               <a:defRPr sz="1600">
-                <a:latin typeface="Microsoft YaHei"/>
+                <a:latin typeface="微软雅黑" panose="020B0503020204020204" charset="-122"/>
               </a:defRPr>
             </a:pPr>
             <a:r>
-              <a:t>非线性模型明显优于线性模型，但还不是 CNN</a:t>
-            </a:r>
+              <a:rPr>
+                <a:sym typeface="+mn-ea"/>
+              </a:rPr>
+              <a:t>1. features.ipynb 已补跑：HOG + color histogram</a:t>
+            </a:r>
+            <a:endParaRPr>
+              <a:sym typeface="+mn-ea"/>
+            </a:endParaRPr>
+          </a:p>
+          <a:p>
+            <a:pPr>
+              <a:spcAft>
+                <a:spcPts val="800"/>
+              </a:spcAft>
+              <a:defRPr sz="1600">
+                <a:latin typeface="微软雅黑" panose="020B0503020204020204" charset="-122"/>
+              </a:defRPr>
+            </a:pPr>
+            <a:r>
+              <a:rPr>
+                <a:sym typeface="+mn-ea"/>
+              </a:rPr>
+              <a:t>2. 跑 FullyConnectedNets.ipynb：多层网络、Dropout、BatchNorm</a:t>
+            </a:r>
+            <a:endParaRPr>
+              <a:sym typeface="+mn-ea"/>
+            </a:endParaRPr>
+          </a:p>
+          <a:p>
+            <a:pPr>
+              <a:spcAft>
+                <a:spcPts val="800"/>
+              </a:spcAft>
+              <a:defRPr sz="1600">
+                <a:latin typeface="微软雅黑" panose="020B0503020204020204" charset="-122"/>
+              </a:defRPr>
+            </a:pPr>
+            <a:r>
+              <a:rPr>
+                <a:sym typeface="+mn-ea"/>
+              </a:rPr>
+              <a:t>3. 扩大 TwoLayerNet epoch 与更细调参</a:t>
+            </a:r>
+            <a:endParaRPr>
+              <a:sym typeface="+mn-ea"/>
+            </a:endParaRPr>
+          </a:p>
+          <a:p>
+            <a:pPr>
+              <a:spcAft>
+                <a:spcPts val="800"/>
+              </a:spcAft>
+              <a:defRPr sz="1600">
+                <a:latin typeface="微软雅黑" panose="020B0503020204020204" charset="-122"/>
+              </a:defRPr>
+            </a:pPr>
+            <a:r>
+              <a:rPr>
+                <a:sym typeface="+mn-ea"/>
+              </a:rPr>
+              <a:t>4. 进入 CNN：利用局部感受野和权重共享</a:t>
+            </a:r>
+            <a:endParaRPr lang="zh-CN" altLang="en-US">
+              <a:sym typeface="+mn-ea"/>
+            </a:endParaRPr>
+          </a:p>
+        </p:txBody>
+      </p:sp>
+      <p:sp>
+        <p:nvSpPr>
+          <p:cNvPr id="6" name="TextBox 2"/>
+          <p:cNvSpPr txBox="1"/>
+          <p:nvPr/>
+        </p:nvSpPr>
+        <p:spPr>
+          <a:xfrm>
+            <a:off x="502920" y="3177540"/>
+            <a:ext cx="10424160" cy="502920"/>
+          </a:xfrm>
+          <a:prstGeom prst="rect">
+            <a:avLst/>
+          </a:prstGeom>
+          <a:noFill/>
+        </p:spPr>
+        <p:txBody>
+          <a:bodyPr wrap="none">
+            <a:spAutoFit/>
+          </a:bodyPr>
+          <a:lstStyle/>
+          <a:p>
+            <a:r>
+              <a:rPr sz="2400" b="1">
+                <a:solidFill>
+                  <a:srgbClr val="1E2328"/>
+                </a:solidFill>
+                <a:latin typeface="微软雅黑" panose="020B0503020204020204" charset="-122"/>
+              </a:rPr>
+              <a:t>下一步计划：从 A1 走向更强模型</a:t>
+            </a:r>
+            <a:endParaRPr sz="2400" b="1">
+              <a:solidFill>
+                <a:srgbClr val="1E2328"/>
+              </a:solidFill>
+              <a:latin typeface="微软雅黑" panose="020B0503020204020204" charset="-122"/>
+            </a:endParaRPr>
           </a:p>
         </p:txBody>
       </p:sp>
@@ -3773,7 +4080,7 @@
         <p:spPr>
           <a:xfrm>
             <a:off x="502920" y="256032"/>
-            <a:ext cx="2286000" cy="237744"/>
+            <a:ext cx="2560320" cy="237744"/>
           </a:xfrm>
           <a:prstGeom prst="rect">
             <a:avLst/>
@@ -3793,7 +4100,7 @@
                 </a:solidFill>
                 <a:latin typeface="Microsoft YaHei"/>
               </a:rPr>
-              <a:t>LIMITS</a:t>
+              <a:t>IMAGE FEATURES</a:t>
             </a:r>
           </a:p>
         </p:txBody>
@@ -3807,7 +4114,7 @@
         <p:spPr>
           <a:xfrm>
             <a:off x="502920" y="502920"/>
-            <a:ext cx="10424160" cy="502920"/>
+            <a:ext cx="10698480" cy="502920"/>
           </a:xfrm>
           <a:prstGeom prst="rect">
             <a:avLst/>
@@ -3827,7 +4134,7 @@
                 </a:solidFill>
                 <a:latin typeface="Microsoft YaHei"/>
               </a:rPr>
-              <a:t>当前局限：还没有进入真正强的图像表示</a:t>
+              <a:t>补充实验：HOG + Color Histogram</a:t>
             </a:r>
           </a:p>
         </p:txBody>
@@ -3841,7 +4148,7 @@
         <p:spPr>
           <a:xfrm>
             <a:off x="685800" y="1234440"/>
-            <a:ext cx="10424160" cy="4389120"/>
+            <a:ext cx="4663440" cy="4389120"/>
           </a:xfrm>
           <a:prstGeom prst="rect">
             <a:avLst/>
@@ -3858,12 +4165,12 @@
               <a:spcAft>
                 <a:spcPts val="800"/>
               </a:spcAft>
-              <a:defRPr sz="1600">
+              <a:defRPr sz="1500">
                 <a:latin typeface="Microsoft YaHei"/>
               </a:defRPr>
             </a:pPr>
             <a:r>
-              <a:t>尚未充分跑 HOG / color histogram features</a:t>
+              <a:t>A1 后半部分要求比较 raw pixels 与 higher-level representations</a:t>
             </a:r>
           </a:p>
           <a:p>
@@ -3871,12 +4178,12 @@
               <a:spcAft>
                 <a:spcPts val="800"/>
               </a:spcAft>
-              <a:defRPr sz="1600">
+              <a:defRPr sz="1500">
                 <a:latin typeface="Microsoft YaHei"/>
               </a:defRPr>
             </a:pPr>
             <a:r>
-              <a:t>FullyConnectedNet 的 dropout / batch normalization 还未展开</a:t>
+              <a:t>本次提取 HOG + HSV color histogram，特征维度 154</a:t>
             </a:r>
           </a:p>
           <a:p>
@@ -3884,12 +4191,12 @@
               <a:spcAft>
                 <a:spcPts val="800"/>
               </a:spcAft>
-              <a:defRPr sz="1600">
+              <a:defRPr sz="1500">
                 <a:latin typeface="Microsoft YaHei"/>
               </a:defRPr>
             </a:pPr>
             <a:r>
-              <a:t>测试集使用 1,000 张快速评估，后续可扩到完整 10,000 张</a:t>
+              <a:t>HOG 关注边缘和梯度方向，color histogram 关注颜色分布</a:t>
             </a:r>
           </a:p>
           <a:p>
@@ -3897,16 +4204,40 @@
               <a:spcAft>
                 <a:spcPts val="800"/>
               </a:spcAft>
-              <a:defRPr sz="1600">
+              <a:defRPr sz="1500">
                 <a:latin typeface="Microsoft YaHei"/>
               </a:defRPr>
             </a:pPr>
             <a:r>
-              <a:t>未使用 CNN，因此没有利用图像局部空间结构</a:t>
-            </a:r>
-          </a:p>
-        </p:txBody>
-      </p:sp>
+              <a:t>这一步不是换模型，而是换输入表示</a:t>
+            </a:r>
+          </a:p>
+        </p:txBody>
+      </p:sp>
+      <p:pic>
+        <p:nvPicPr>
+          <p:cNvPr id="5" name="Picture 4" descr="feature_vs_raw_accuracy.png"/>
+          <p:cNvPicPr>
+            <a:picLocks noChangeAspect="1"/>
+          </p:cNvPicPr>
+          <p:nvPr/>
+        </p:nvPicPr>
+        <p:blipFill>
+          <a:blip r:embed="rId2"/>
+          <a:stretch>
+            <a:fillRect/>
+          </a:stretch>
+        </p:blipFill>
+        <p:spPr>
+          <a:xfrm>
+            <a:off x="5577840" y="1097280"/>
+            <a:ext cx="5852160" cy="4023360"/>
+          </a:xfrm>
+          <a:prstGeom prst="rect">
+            <a:avLst/>
+          </a:prstGeom>
+        </p:spPr>
+      </p:pic>
     </p:spTree>
   </p:cSld>
   <p:clrMapOvr>
@@ -3942,7 +4273,7 @@
         <p:spPr>
           <a:xfrm>
             <a:off x="502920" y="256032"/>
-            <a:ext cx="2286000" cy="237744"/>
+            <a:ext cx="2560320" cy="237744"/>
           </a:xfrm>
           <a:prstGeom prst="rect">
             <a:avLst/>
@@ -3962,7 +4293,7 @@
                 </a:solidFill>
                 <a:latin typeface="Microsoft YaHei"/>
               </a:rPr>
-              <a:t>NEXT</a:t>
+              <a:t>FEATURE TUNING</a:t>
             </a:r>
           </a:p>
         </p:txBody>
@@ -3976,7 +4307,7 @@
         <p:spPr>
           <a:xfrm>
             <a:off x="502920" y="502920"/>
-            <a:ext cx="10424160" cy="502920"/>
+            <a:ext cx="10698480" cy="502920"/>
           </a:xfrm>
           <a:prstGeom prst="rect">
             <a:avLst/>
@@ -3996,21 +4327,69 @@
                 </a:solidFill>
                 <a:latin typeface="Microsoft YaHei"/>
               </a:rPr>
-              <a:t>下一步计划：从 A1 走向更强模型</a:t>
-            </a:r>
-          </a:p>
-        </p:txBody>
-      </p:sp>
-      <p:sp>
-        <p:nvSpPr>
-          <p:cNvPr id="4" name="TextBox 3"/>
+              <a:t>特征版模型调参结果</a:t>
+            </a:r>
+          </a:p>
+        </p:txBody>
+      </p:sp>
+      <p:pic>
+        <p:nvPicPr>
+          <p:cNvPr id="4" name="Picture 3" descr="features_softmax_hyperparam_heatmap.png"/>
+          <p:cNvPicPr>
+            <a:picLocks noChangeAspect="1"/>
+          </p:cNvPicPr>
+          <p:nvPr/>
+        </p:nvPicPr>
+        <p:blipFill>
+          <a:blip r:embed="rId2"/>
+          <a:stretch>
+            <a:fillRect/>
+          </a:stretch>
+        </p:blipFill>
+        <p:spPr>
+          <a:xfrm>
+            <a:off x="594360" y="1051560"/>
+            <a:ext cx="5303520" cy="3840480"/>
+          </a:xfrm>
+          <a:prstGeom prst="rect">
+            <a:avLst/>
+          </a:prstGeom>
+        </p:spPr>
+      </p:pic>
+      <p:pic>
+        <p:nvPicPr>
+          <p:cNvPr id="5" name="Picture 4" descr="features_twolayer_config_comparison.png"/>
+          <p:cNvPicPr>
+            <a:picLocks noChangeAspect="1"/>
+          </p:cNvPicPr>
+          <p:nvPr/>
+        </p:nvPicPr>
+        <p:blipFill>
+          <a:blip r:embed="rId3"/>
+          <a:stretch>
+            <a:fillRect/>
+          </a:stretch>
+        </p:blipFill>
+        <p:spPr>
+          <a:xfrm>
+            <a:off x="6080760" y="1051560"/>
+            <a:ext cx="5486400" cy="3840480"/>
+          </a:xfrm>
+          <a:prstGeom prst="rect">
+            <a:avLst/>
+          </a:prstGeom>
+        </p:spPr>
+      </p:pic>
+      <p:sp>
+        <p:nvSpPr>
+          <p:cNvPr id="6" name="TextBox 5"/>
           <p:cNvSpPr txBox="1"/>
           <p:nvPr/>
         </p:nvSpPr>
         <p:spPr>
           <a:xfrm>
-            <a:off x="685800" y="1234440"/>
-            <a:ext cx="10424160" cy="4389120"/>
+            <a:off x="685800" y="5577840"/>
+            <a:ext cx="10515600" cy="365760"/>
           </a:xfrm>
           <a:prstGeom prst="rect">
             <a:avLst/>
@@ -4023,55 +4402,14 @@
           </a:bodyPr>
           <a:lstStyle/>
           <a:p>
-            <a:pPr>
-              <a:spcAft>
-                <a:spcPts val="800"/>
-              </a:spcAft>
-              <a:defRPr sz="1600">
+            <a:r>
+              <a:rPr sz="1800" b="1">
+                <a:solidFill>
+                  <a:srgbClr val="4F8968"/>
+                </a:solidFill>
                 <a:latin typeface="Microsoft YaHei"/>
-              </a:defRPr>
-            </a:pPr>
-            <a:r>
-              <a:t>1. 跑 features.ipynb：HOG + color histogram</a:t>
-            </a:r>
-          </a:p>
-          <a:p>
-            <a:pPr>
-              <a:spcAft>
-                <a:spcPts val="800"/>
-              </a:spcAft>
-              <a:defRPr sz="1600">
-                <a:latin typeface="Microsoft YaHei"/>
-              </a:defRPr>
-            </a:pPr>
-            <a:r>
-              <a:t>2. 跑 FullyConnectedNets.ipynb：多层网络、Dropout、BatchNorm</a:t>
-            </a:r>
-          </a:p>
-          <a:p>
-            <a:pPr>
-              <a:spcAft>
-                <a:spcPts val="800"/>
-              </a:spcAft>
-              <a:defRPr sz="1600">
-                <a:latin typeface="Microsoft YaHei"/>
-              </a:defRPr>
-            </a:pPr>
-            <a:r>
-              <a:t>3. 扩大 TwoLayerNet epoch 与更细调参</a:t>
-            </a:r>
-          </a:p>
-          <a:p>
-            <a:pPr>
-              <a:spcAft>
-                <a:spcPts val="800"/>
-              </a:spcAft>
-              <a:defRPr sz="1600">
-                <a:latin typeface="Microsoft YaHei"/>
-              </a:defRPr>
-            </a:pPr>
-            <a:r>
-              <a:t>4. 进入 CNN：利用局部感受野和权重共享</a:t>
+              </a:rPr>
+              <a:t>Best feature TwoLayerNet: val=0.605, test=0.576</a:t>
             </a:r>
           </a:p>
         </p:txBody>
@@ -4084,7 +4422,7 @@
 </p:sld>
 </file>
 
-<file path=ppt/slides/slide2.xml><?xml version="1.0" encoding="utf-8"?>
+<file path=ppt/slides/slide15.xml><?xml version="1.0" encoding="utf-8"?>
 <p:sld xmlns:a="http://schemas.openxmlformats.org/drawingml/2006/main" xmlns:p="http://schemas.openxmlformats.org/presentationml/2006/main" xmlns:r="http://schemas.openxmlformats.org/officeDocument/2006/relationships">
   <p:cSld>
     <p:bg>
@@ -4111,7 +4449,7 @@
         <p:spPr>
           <a:xfrm>
             <a:off x="502920" y="256032"/>
-            <a:ext cx="2286000" cy="237744"/>
+            <a:ext cx="2560320" cy="237744"/>
           </a:xfrm>
           <a:prstGeom prst="rect">
             <a:avLst/>
@@ -4131,7 +4469,7 @@
                 </a:solidFill>
                 <a:latin typeface="Microsoft YaHei"/>
               </a:rPr>
-              <a:t>BACKGROUND</a:t>
+              <a:t>UPDATED CONCLUSION</a:t>
             </a:r>
           </a:p>
         </p:txBody>
@@ -4145,7 +4483,7 @@
         <p:spPr>
           <a:xfrm>
             <a:off x="502920" y="502920"/>
-            <a:ext cx="10424160" cy="502920"/>
+            <a:ext cx="10698480" cy="502920"/>
           </a:xfrm>
           <a:prstGeom prst="rect">
             <a:avLst/>
@@ -4165,7 +4503,7 @@
                 </a:solidFill>
                 <a:latin typeface="Microsoft YaHei"/>
               </a:rPr>
-              <a:t>任务背景：从图像分类 pipeline 进入神经网络</a:t>
+              <a:t>更新后的 Week5 结论</a:t>
             </a:r>
           </a:p>
         </p:txBody>
@@ -4178,8 +4516,8 @@
         </p:nvSpPr>
         <p:spPr>
           <a:xfrm>
-            <a:off x="685800" y="1234440"/>
-            <a:ext cx="10515600" cy="4389120"/>
+            <a:off x="731520" y="1234440"/>
+            <a:ext cx="10424160" cy="4389120"/>
           </a:xfrm>
           <a:prstGeom prst="rect">
             <a:avLst/>
@@ -4196,12 +4534,12 @@
               <a:spcAft>
                 <a:spcPts val="800"/>
               </a:spcAft>
-              <a:defRPr sz="1600">
+              <a:defRPr sz="1800">
                 <a:latin typeface="Microsoft YaHei"/>
               </a:defRPr>
             </a:pPr>
             <a:r>
-              <a:t>CS231n A1 关注图像分类的完整工程链路</a:t>
+              <a:t>Softmax: raw pixels 0.359 -&gt; features 0.420</a:t>
             </a:r>
           </a:p>
           <a:p>
@@ -4209,12 +4547,12 @@
               <a:spcAft>
                 <a:spcPts val="800"/>
               </a:spcAft>
-              <a:defRPr sz="1600">
+              <a:defRPr sz="1800">
                 <a:latin typeface="Microsoft YaHei"/>
               </a:defRPr>
             </a:pPr>
             <a:r>
-              <a:t>从 kNN 到 Softmax，再到两层神经网络</a:t>
+              <a:t>TwoLayerNet: raw pixels 0.493 -&gt; features 0.576</a:t>
             </a:r>
           </a:p>
           <a:p>
@@ -4222,12 +4560,12 @@
               <a:spcAft>
                 <a:spcPts val="800"/>
               </a:spcAft>
-              <a:defRPr sz="1600">
+              <a:defRPr sz="1800">
                 <a:latin typeface="Microsoft YaHei"/>
               </a:defRPr>
             </a:pPr>
             <a:r>
-              <a:t>核心学习点：数据划分、loss、gradient、regularization、hyperparameter tuning</a:t>
+              <a:t>手工图像特征能显著提升传统分类器，因为它更接近边缘、颜色、轮廓等视觉语义</a:t>
             </a:r>
           </a:p>
           <a:p>
@@ -4235,12 +4573,12 @@
               <a:spcAft>
                 <a:spcPts val="800"/>
               </a:spcAft>
-              <a:defRPr sz="1600">
+              <a:defRPr sz="1800">
                 <a:latin typeface="Microsoft YaHei"/>
               </a:defRPr>
             </a:pPr>
             <a:r>
-              <a:t>本实验不是提交作业，而是本地复现与组会汇报</a:t>
+              <a:t>CNN 后续要学习的事情，本质上就是自动学习比 HOG 更强的局部图像特征</a:t>
             </a:r>
           </a:p>
         </p:txBody>
@@ -4253,8 +4591,8 @@
 </p:sld>
 </file>
 
-<file path=ppt/slides/slide3.xml><?xml version="1.0" encoding="utf-8"?>
-<p:sld xmlns:a="http://schemas.openxmlformats.org/drawingml/2006/main" xmlns:p="http://schemas.openxmlformats.org/presentationml/2006/main" xmlns:r="http://schemas.openxmlformats.org/officeDocument/2006/relationships">
+<file path=ppt/slides/slide2.xml><?xml version="1.0" encoding="utf-8"?>
+<p:sld xmlns:a="http://schemas.openxmlformats.org/drawingml/2006/main" xmlns:r="http://schemas.openxmlformats.org/officeDocument/2006/relationships" xmlns:p="http://schemas.openxmlformats.org/presentationml/2006/main">
   <p:cSld>
     <p:bg>
       <p:bgPr>
@@ -4298,10 +4636,16 @@
                 <a:solidFill>
                   <a:srgbClr val="5F6F82"/>
                 </a:solidFill>
-                <a:latin typeface="Microsoft YaHei"/>
+                <a:latin typeface="微软雅黑" panose="020B0503020204020204" charset="-122"/>
               </a:rPr>
               <a:t>DATASET</a:t>
             </a:r>
+            <a:endParaRPr sz="900" b="1">
+              <a:solidFill>
+                <a:srgbClr val="5F6F82"/>
+              </a:solidFill>
+              <a:latin typeface="微软雅黑" panose="020B0503020204020204" charset="-122"/>
+            </a:endParaRPr>
           </a:p>
         </p:txBody>
       </p:sp>
@@ -4332,10 +4676,16 @@
                 <a:solidFill>
                   <a:srgbClr val="1E2328"/>
                 </a:solidFill>
-                <a:latin typeface="Microsoft YaHei"/>
+                <a:latin typeface="微软雅黑" panose="020B0503020204020204" charset="-122"/>
               </a:rPr>
               <a:t>CIFAR-10：10 类 32×32 彩色图像</a:t>
             </a:r>
+            <a:endParaRPr sz="2400" b="1">
+              <a:solidFill>
+                <a:srgbClr val="1E2328"/>
+              </a:solidFill>
+              <a:latin typeface="微软雅黑" panose="020B0503020204020204" charset="-122"/>
+            </a:endParaRPr>
           </a:p>
         </p:txBody>
       </p:sp>
@@ -4366,7 +4716,7 @@
                 <a:spcPts val="800"/>
               </a:spcAft>
               <a:defRPr sz="1600">
-                <a:latin typeface="Microsoft YaHei"/>
+                <a:latin typeface="微软雅黑" panose="020B0503020204020204" charset="-122"/>
               </a:defRPr>
             </a:pPr>
             <a:r>
@@ -4379,7 +4729,7 @@
                 <a:spcPts val="800"/>
               </a:spcAft>
               <a:defRPr sz="1600">
-                <a:latin typeface="Microsoft YaHei"/>
+                <a:latin typeface="微软雅黑" panose="020B0503020204020204" charset="-122"/>
               </a:defRPr>
             </a:pPr>
             <a:r>
@@ -4392,7 +4742,7 @@
                 <a:spcPts val="800"/>
               </a:spcAft>
               <a:defRPr sz="1600">
-                <a:latin typeface="Microsoft YaHei"/>
+                <a:latin typeface="微软雅黑" panose="020B0503020204020204" charset="-122"/>
               </a:defRPr>
             </a:pPr>
             <a:r>
@@ -4405,7 +4755,7 @@
                 <a:spcPts val="800"/>
               </a:spcAft>
               <a:defRPr sz="1600">
-                <a:latin typeface="Microsoft YaHei"/>
+                <a:latin typeface="微软雅黑" panose="020B0503020204020204" charset="-122"/>
               </a:defRPr>
             </a:pPr>
             <a:r>
@@ -4423,7 +4773,7 @@
           <p:nvPr/>
         </p:nvPicPr>
         <p:blipFill>
-          <a:blip r:embed="rId2"/>
+          <a:blip r:embed="rId1"/>
           <a:stretch>
             <a:fillRect/>
           </a:stretch>
@@ -4446,8 +4796,8 @@
 </p:sld>
 </file>
 
-<file path=ppt/slides/slide4.xml><?xml version="1.0" encoding="utf-8"?>
-<p:sld xmlns:a="http://schemas.openxmlformats.org/drawingml/2006/main" xmlns:p="http://schemas.openxmlformats.org/presentationml/2006/main" xmlns:r="http://schemas.openxmlformats.org/officeDocument/2006/relationships">
+<file path=ppt/slides/slide3.xml><?xml version="1.0" encoding="utf-8"?>
+<p:sld xmlns:a="http://schemas.openxmlformats.org/drawingml/2006/main" xmlns:r="http://schemas.openxmlformats.org/officeDocument/2006/relationships" xmlns:p="http://schemas.openxmlformats.org/presentationml/2006/main">
   <p:cSld>
     <p:bg>
       <p:bgPr>
@@ -4491,10 +4841,16 @@
                 <a:solidFill>
                   <a:srgbClr val="5F6F82"/>
                 </a:solidFill>
-                <a:latin typeface="Microsoft YaHei"/>
+                <a:latin typeface="微软雅黑" panose="020B0503020204020204" charset="-122"/>
               </a:rPr>
               <a:t>WORKFLOW</a:t>
             </a:r>
+            <a:endParaRPr sz="900" b="1">
+              <a:solidFill>
+                <a:srgbClr val="5F6F82"/>
+              </a:solidFill>
+              <a:latin typeface="微软雅黑" panose="020B0503020204020204" charset="-122"/>
+            </a:endParaRPr>
           </a:p>
         </p:txBody>
       </p:sp>
@@ -4525,10 +4881,16 @@
                 <a:solidFill>
                   <a:srgbClr val="1E2328"/>
                 </a:solidFill>
-                <a:latin typeface="Microsoft YaHei"/>
+                <a:latin typeface="微软雅黑" panose="020B0503020204020204" charset="-122"/>
               </a:rPr>
               <a:t>实验流程：训练、调参、验证、测试与可视化</a:t>
             </a:r>
+            <a:endParaRPr sz="2400" b="1">
+              <a:solidFill>
+                <a:srgbClr val="1E2328"/>
+              </a:solidFill>
+              <a:latin typeface="微软雅黑" panose="020B0503020204020204" charset="-122"/>
+            </a:endParaRPr>
           </a:p>
         </p:txBody>
       </p:sp>
@@ -4541,7 +4903,7 @@
         <p:spPr>
           <a:xfrm>
             <a:off x="685800" y="1234440"/>
-            <a:ext cx="10515600" cy="4389120"/>
+            <a:ext cx="4009390" cy="1732915"/>
           </a:xfrm>
           <a:prstGeom prst="rect">
             <a:avLst/>
@@ -4559,7 +4921,7 @@
                 <a:spcPts val="800"/>
               </a:spcAft>
               <a:defRPr sz="1600">
-                <a:latin typeface="Microsoft YaHei"/>
+                <a:latin typeface="微软雅黑" panose="020B0503020204020204" charset="-122"/>
               </a:defRPr>
             </a:pPr>
             <a:r>
@@ -4572,7 +4934,7 @@
                 <a:spcPts val="800"/>
               </a:spcAft>
               <a:defRPr sz="1600">
-                <a:latin typeface="Microsoft YaHei"/>
+                <a:latin typeface="微软雅黑" panose="020B0503020204020204" charset="-122"/>
               </a:defRPr>
             </a:pPr>
             <a:r>
@@ -4585,7 +4947,7 @@
                 <a:spcPts val="800"/>
               </a:spcAft>
               <a:defRPr sz="1600">
-                <a:latin typeface="Microsoft YaHei"/>
+                <a:latin typeface="微软雅黑" panose="020B0503020204020204" charset="-122"/>
               </a:defRPr>
             </a:pPr>
             <a:r>
@@ -4598,7 +4960,7 @@
                 <a:spcPts val="800"/>
               </a:spcAft>
               <a:defRPr sz="1600">
-                <a:latin typeface="Microsoft YaHei"/>
+                <a:latin typeface="微软雅黑" panose="020B0503020204020204" charset="-122"/>
               </a:defRPr>
             </a:pPr>
             <a:r>
@@ -4611,12 +4973,9 @@
                 <a:spcPts val="800"/>
               </a:spcAft>
               <a:defRPr sz="1600">
-                <a:latin typeface="Microsoft YaHei"/>
+                <a:latin typeface="微软雅黑" panose="020B0503020204020204" charset="-122"/>
               </a:defRPr>
             </a:pPr>
-            <a:r>
-              <a:t>5. 汇总 JSON、Markdown 报告、PNG 图表和 PPT</a:t>
-            </a:r>
           </a:p>
         </p:txBody>
       </p:sp>
@@ -4628,8 +4987,8 @@
 </p:sld>
 </file>
 
-<file path=ppt/slides/slide5.xml><?xml version="1.0" encoding="utf-8"?>
-<p:sld xmlns:a="http://schemas.openxmlformats.org/drawingml/2006/main" xmlns:p="http://schemas.openxmlformats.org/presentationml/2006/main" xmlns:r="http://schemas.openxmlformats.org/officeDocument/2006/relationships">
+<file path=ppt/slides/slide4.xml><?xml version="1.0" encoding="utf-8"?>
+<p:sld xmlns:a="http://schemas.openxmlformats.org/drawingml/2006/main" xmlns:r="http://schemas.openxmlformats.org/officeDocument/2006/relationships" xmlns:p="http://schemas.openxmlformats.org/presentationml/2006/main">
   <p:cSld>
     <p:bg>
       <p:bgPr>
@@ -4673,10 +5032,16 @@
                 <a:solidFill>
                   <a:srgbClr val="5F6F82"/>
                 </a:solidFill>
-                <a:latin typeface="Microsoft YaHei"/>
+                <a:latin typeface="微软雅黑" panose="020B0503020204020204" charset="-122"/>
               </a:rPr>
               <a:t>KNN</a:t>
             </a:r>
+            <a:endParaRPr sz="900" b="1">
+              <a:solidFill>
+                <a:srgbClr val="5F6F82"/>
+              </a:solidFill>
+              <a:latin typeface="微软雅黑" panose="020B0503020204020204" charset="-122"/>
+            </a:endParaRPr>
           </a:p>
         </p:txBody>
       </p:sp>
@@ -4707,10 +5072,16 @@
                 <a:solidFill>
                   <a:srgbClr val="1E2328"/>
                 </a:solidFill>
-                <a:latin typeface="Microsoft YaHei"/>
+                <a:latin typeface="微软雅黑" panose="020B0503020204020204" charset="-122"/>
               </a:rPr>
               <a:t>kNN：简单但被原始像素距离限制</a:t>
             </a:r>
+            <a:endParaRPr sz="2400" b="1">
+              <a:solidFill>
+                <a:srgbClr val="1E2328"/>
+              </a:solidFill>
+              <a:latin typeface="微软雅黑" panose="020B0503020204020204" charset="-122"/>
+            </a:endParaRPr>
           </a:p>
         </p:txBody>
       </p:sp>
@@ -4741,7 +5112,7 @@
                 <a:spcPts val="800"/>
               </a:spcAft>
               <a:defRPr sz="1600">
-                <a:latin typeface="Microsoft YaHei"/>
+                <a:latin typeface="微软雅黑" panose="020B0503020204020204" charset="-122"/>
               </a:defRPr>
             </a:pPr>
             <a:r>
@@ -4754,7 +5125,7 @@
                 <a:spcPts val="800"/>
               </a:spcAft>
               <a:defRPr sz="1600">
-                <a:latin typeface="Microsoft YaHei"/>
+                <a:latin typeface="微软雅黑" panose="020B0503020204020204" charset="-122"/>
               </a:defRPr>
             </a:pPr>
             <a:r>
@@ -4767,7 +5138,7 @@
                 <a:spcPts val="800"/>
               </a:spcAft>
               <a:defRPr sz="1600">
-                <a:latin typeface="Microsoft YaHei"/>
+                <a:latin typeface="微软雅黑" panose="020B0503020204020204" charset="-122"/>
               </a:defRPr>
             </a:pPr>
             <a:r>
@@ -4780,7 +5151,7 @@
                 <a:spcPts val="800"/>
               </a:spcAft>
               <a:defRPr sz="1600">
-                <a:latin typeface="Microsoft YaHei"/>
+                <a:latin typeface="微软雅黑" panose="020B0503020204020204" charset="-122"/>
               </a:defRPr>
             </a:pPr>
             <a:r>
@@ -4798,7 +5169,7 @@
           <p:nvPr/>
         </p:nvPicPr>
         <p:blipFill>
-          <a:blip r:embed="rId2"/>
+          <a:blip r:embed="rId1"/>
           <a:stretch>
             <a:fillRect/>
           </a:stretch>
@@ -4821,8 +5192,8 @@
 </p:sld>
 </file>
 
-<file path=ppt/slides/slide6.xml><?xml version="1.0" encoding="utf-8"?>
-<p:sld xmlns:a="http://schemas.openxmlformats.org/drawingml/2006/main" xmlns:p="http://schemas.openxmlformats.org/presentationml/2006/main" xmlns:r="http://schemas.openxmlformats.org/officeDocument/2006/relationships">
+<file path=ppt/slides/slide5.xml><?xml version="1.0" encoding="utf-8"?>
+<p:sld xmlns:a="http://schemas.openxmlformats.org/drawingml/2006/main" xmlns:r="http://schemas.openxmlformats.org/officeDocument/2006/relationships" xmlns:p="http://schemas.openxmlformats.org/presentationml/2006/main">
   <p:cSld>
     <p:bg>
       <p:bgPr>
@@ -4866,10 +5237,16 @@
                 <a:solidFill>
                   <a:srgbClr val="5F6F82"/>
                 </a:solidFill>
-                <a:latin typeface="Microsoft YaHei"/>
+                <a:latin typeface="微软雅黑" panose="020B0503020204020204" charset="-122"/>
               </a:rPr>
               <a:t>SOFTMAX</a:t>
             </a:r>
+            <a:endParaRPr sz="900" b="1">
+              <a:solidFill>
+                <a:srgbClr val="5F6F82"/>
+              </a:solidFill>
+              <a:latin typeface="微软雅黑" panose="020B0503020204020204" charset="-122"/>
+            </a:endParaRPr>
           </a:p>
         </p:txBody>
       </p:sp>
@@ -4900,10 +5277,16 @@
                 <a:solidFill>
                   <a:srgbClr val="1E2328"/>
                 </a:solidFill>
-                <a:latin typeface="Microsoft YaHei"/>
+                <a:latin typeface="微软雅黑" panose="020B0503020204020204" charset="-122"/>
               </a:rPr>
               <a:t>Softmax：线性分类器受益于调参和更多数据</a:t>
             </a:r>
+            <a:endParaRPr sz="2400" b="1">
+              <a:solidFill>
+                <a:srgbClr val="1E2328"/>
+              </a:solidFill>
+              <a:latin typeface="微软雅黑" panose="020B0503020204020204" charset="-122"/>
+            </a:endParaRPr>
           </a:p>
         </p:txBody>
       </p:sp>
@@ -4934,7 +5317,7 @@
                 <a:spcPts val="800"/>
               </a:spcAft>
               <a:defRPr sz="1600">
-                <a:latin typeface="Microsoft YaHei"/>
+                <a:latin typeface="微软雅黑" panose="020B0503020204020204" charset="-122"/>
               </a:defRPr>
             </a:pPr>
             <a:r>
@@ -4947,7 +5330,7 @@
                 <a:spcPts val="800"/>
               </a:spcAft>
               <a:defRPr sz="1600">
-                <a:latin typeface="Microsoft YaHei"/>
+                <a:latin typeface="微软雅黑" panose="020B0503020204020204" charset="-122"/>
               </a:defRPr>
             </a:pPr>
             <a:r>
@@ -4960,7 +5343,7 @@
                 <a:spcPts val="800"/>
               </a:spcAft>
               <a:defRPr sz="1600">
-                <a:latin typeface="Microsoft YaHei"/>
+                <a:latin typeface="微软雅黑" panose="020B0503020204020204" charset="-122"/>
               </a:defRPr>
             </a:pPr>
             <a:r>
@@ -4973,7 +5356,7 @@
                 <a:spcPts val="800"/>
               </a:spcAft>
               <a:defRPr sz="1600">
-                <a:latin typeface="Microsoft YaHei"/>
+                <a:latin typeface="微软雅黑" panose="020B0503020204020204" charset="-122"/>
               </a:defRPr>
             </a:pPr>
             <a:r>
@@ -4991,7 +5374,7 @@
           <p:nvPr/>
         </p:nvPicPr>
         <p:blipFill>
-          <a:blip r:embed="rId2"/>
+          <a:blip r:embed="rId1"/>
           <a:stretch>
             <a:fillRect/>
           </a:stretch>
@@ -5014,8 +5397,8 @@
 </p:sld>
 </file>
 
-<file path=ppt/slides/slide7.xml><?xml version="1.0" encoding="utf-8"?>
-<p:sld xmlns:a="http://schemas.openxmlformats.org/drawingml/2006/main" xmlns:p="http://schemas.openxmlformats.org/presentationml/2006/main" xmlns:r="http://schemas.openxmlformats.org/officeDocument/2006/relationships">
+<file path=ppt/slides/slide6.xml><?xml version="1.0" encoding="utf-8"?>
+<p:sld xmlns:a="http://schemas.openxmlformats.org/drawingml/2006/main" xmlns:r="http://schemas.openxmlformats.org/officeDocument/2006/relationships" xmlns:p="http://schemas.openxmlformats.org/presentationml/2006/main">
   <p:cSld>
     <p:bg>
       <p:bgPr>
@@ -5059,10 +5442,16 @@
                 <a:solidFill>
                   <a:srgbClr val="5F6F82"/>
                 </a:solidFill>
-                <a:latin typeface="Microsoft YaHei"/>
+                <a:latin typeface="微软雅黑" panose="020B0503020204020204" charset="-122"/>
               </a:rPr>
               <a:t>TWO-LAYER NET</a:t>
             </a:r>
+            <a:endParaRPr sz="900" b="1">
+              <a:solidFill>
+                <a:srgbClr val="5F6F82"/>
+              </a:solidFill>
+              <a:latin typeface="微软雅黑" panose="020B0503020204020204" charset="-122"/>
+            </a:endParaRPr>
           </a:p>
         </p:txBody>
       </p:sp>
@@ -5093,10 +5482,16 @@
                 <a:solidFill>
                   <a:srgbClr val="1E2328"/>
                 </a:solidFill>
-                <a:latin typeface="Microsoft YaHei"/>
+                <a:latin typeface="微软雅黑" panose="020B0503020204020204" charset="-122"/>
               </a:rPr>
               <a:t>TwoLayerNet：非线性隐藏层带来明显提升</a:t>
             </a:r>
+            <a:endParaRPr sz="2400" b="1">
+              <a:solidFill>
+                <a:srgbClr val="1E2328"/>
+              </a:solidFill>
+              <a:latin typeface="微软雅黑" panose="020B0503020204020204" charset="-122"/>
+            </a:endParaRPr>
           </a:p>
         </p:txBody>
       </p:sp>
@@ -5127,7 +5522,7 @@
                 <a:spcPts val="800"/>
               </a:spcAft>
               <a:defRPr sz="1400">
-                <a:latin typeface="Microsoft YaHei"/>
+                <a:latin typeface="微软雅黑" panose="020B0503020204020204" charset="-122"/>
               </a:defRPr>
             </a:pPr>
             <a:r>
@@ -5140,7 +5535,7 @@
                 <a:spcPts val="800"/>
               </a:spcAft>
               <a:defRPr sz="1400">
-                <a:latin typeface="Microsoft YaHei"/>
+                <a:latin typeface="微软雅黑" panose="020B0503020204020204" charset="-122"/>
               </a:defRPr>
             </a:pPr>
             <a:r>
@@ -5153,7 +5548,7 @@
                 <a:spcPts val="800"/>
               </a:spcAft>
               <a:defRPr sz="1400">
-                <a:latin typeface="Microsoft YaHei"/>
+                <a:latin typeface="微软雅黑" panose="020B0503020204020204" charset="-122"/>
               </a:defRPr>
             </a:pPr>
             <a:r>
@@ -5166,7 +5561,7 @@
                 <a:spcPts val="800"/>
               </a:spcAft>
               <a:defRPr sz="1400">
-                <a:latin typeface="Microsoft YaHei"/>
+                <a:latin typeface="微软雅黑" panose="020B0503020204020204" charset="-122"/>
               </a:defRPr>
             </a:pPr>
             <a:r>
@@ -5184,15 +5579,15 @@
           <p:nvPr/>
         </p:nvPicPr>
         <p:blipFill>
-          <a:blip r:embed="rId2"/>
+          <a:blip r:embed="rId1"/>
           <a:stretch>
             <a:fillRect/>
           </a:stretch>
         </p:blipFill>
         <p:spPr>
           <a:xfrm>
-            <a:off x="4709160" y="1005840"/>
-            <a:ext cx="7040880" cy="4480560"/>
+            <a:off x="5099050" y="1253490"/>
+            <a:ext cx="6650990" cy="4232910"/>
           </a:xfrm>
           <a:prstGeom prst="rect">
             <a:avLst/>
@@ -5207,8 +5602,8 @@
 </p:sld>
 </file>
 
-<file path=ppt/slides/slide8.xml><?xml version="1.0" encoding="utf-8"?>
-<p:sld xmlns:a="http://schemas.openxmlformats.org/drawingml/2006/main" xmlns:p="http://schemas.openxmlformats.org/presentationml/2006/main" xmlns:r="http://schemas.openxmlformats.org/officeDocument/2006/relationships">
+<file path=ppt/slides/slide7.xml><?xml version="1.0" encoding="utf-8"?>
+<p:sld xmlns:a="http://schemas.openxmlformats.org/drawingml/2006/main" xmlns:r="http://schemas.openxmlformats.org/officeDocument/2006/relationships" xmlns:p="http://schemas.openxmlformats.org/presentationml/2006/main">
   <p:cSld>
     <p:bg>
       <p:bgPr>
@@ -5252,10 +5647,16 @@
                 <a:solidFill>
                   <a:srgbClr val="5F6F82"/>
                 </a:solidFill>
-                <a:latin typeface="Microsoft YaHei"/>
+                <a:latin typeface="微软雅黑" panose="020B0503020204020204" charset="-122"/>
               </a:rPr>
               <a:t>COMPARISON</a:t>
             </a:r>
+            <a:endParaRPr sz="900" b="1">
+              <a:solidFill>
+                <a:srgbClr val="5F6F82"/>
+              </a:solidFill>
+              <a:latin typeface="微软雅黑" panose="020B0503020204020204" charset="-122"/>
+            </a:endParaRPr>
           </a:p>
         </p:txBody>
       </p:sp>
@@ -5286,10 +5687,16 @@
                 <a:solidFill>
                   <a:srgbClr val="1E2328"/>
                 </a:solidFill>
-                <a:latin typeface="Microsoft YaHei"/>
+                <a:latin typeface="微软雅黑" panose="020B0503020204020204" charset="-122"/>
               </a:rPr>
               <a:t>模型对比：TwoLayerNet 在 raw pixels 上领先</a:t>
             </a:r>
+            <a:endParaRPr sz="2400" b="1">
+              <a:solidFill>
+                <a:srgbClr val="1E2328"/>
+              </a:solidFill>
+              <a:latin typeface="微软雅黑" panose="020B0503020204020204" charset="-122"/>
+            </a:endParaRPr>
           </a:p>
         </p:txBody>
       </p:sp>
@@ -5302,7 +5709,7 @@
           <p:nvPr/>
         </p:nvPicPr>
         <p:blipFill>
-          <a:blip r:embed="rId2"/>
+          <a:blip r:embed="rId1"/>
           <a:stretch>
             <a:fillRect/>
           </a:stretch>
@@ -5325,8 +5732,8 @@
 </p:sld>
 </file>
 
-<file path=ppt/slides/slide9.xml><?xml version="1.0" encoding="utf-8"?>
-<p:sld xmlns:a="http://schemas.openxmlformats.org/drawingml/2006/main" xmlns:p="http://schemas.openxmlformats.org/presentationml/2006/main" xmlns:r="http://schemas.openxmlformats.org/officeDocument/2006/relationships">
+<file path=ppt/slides/slide8.xml><?xml version="1.0" encoding="utf-8"?>
+<p:sld xmlns:a="http://schemas.openxmlformats.org/drawingml/2006/main" xmlns:r="http://schemas.openxmlformats.org/officeDocument/2006/relationships" xmlns:p="http://schemas.openxmlformats.org/presentationml/2006/main">
   <p:cSld>
     <p:bg>
       <p:bgPr>
@@ -5370,10 +5777,16 @@
                 <a:solidFill>
                   <a:srgbClr val="5F6F82"/>
                 </a:solidFill>
-                <a:latin typeface="Microsoft YaHei"/>
+                <a:latin typeface="微软雅黑" panose="020B0503020204020204" charset="-122"/>
               </a:rPr>
               <a:t>SCALE EFFECT</a:t>
             </a:r>
+            <a:endParaRPr sz="900" b="1">
+              <a:solidFill>
+                <a:srgbClr val="5F6F82"/>
+              </a:solidFill>
+              <a:latin typeface="微软雅黑" panose="020B0503020204020204" charset="-122"/>
+            </a:endParaRPr>
           </a:p>
         </p:txBody>
       </p:sp>
@@ -5404,10 +5817,16 @@
                 <a:solidFill>
                   <a:srgbClr val="1E2328"/>
                 </a:solidFill>
-                <a:latin typeface="Microsoft YaHei"/>
+                <a:latin typeface="微软雅黑" panose="020B0503020204020204" charset="-122"/>
               </a:rPr>
               <a:t>数据规模影响：线性与非线性模型更能利用更多数据</a:t>
             </a:r>
+            <a:endParaRPr sz="2400" b="1">
+              <a:solidFill>
+                <a:srgbClr val="1E2328"/>
+              </a:solidFill>
+              <a:latin typeface="微软雅黑" panose="020B0503020204020204" charset="-122"/>
+            </a:endParaRPr>
           </a:p>
         </p:txBody>
       </p:sp>
@@ -5420,7 +5839,7 @@
           <p:nvPr/>
         </p:nvPicPr>
         <p:blipFill>
-          <a:blip r:embed="rId2"/>
+          <a:blip r:embed="rId1"/>
           <a:stretch>
             <a:fillRect/>
           </a:stretch>
@@ -5462,7 +5881,7 @@
                 <a:spcPts val="800"/>
               </a:spcAft>
               <a:defRPr sz="1500">
-                <a:latin typeface="Microsoft YaHei"/>
+                <a:latin typeface="微软雅黑" panose="020B0503020204020204" charset="-122"/>
               </a:defRPr>
             </a:pPr>
             <a:r>
@@ -5475,7 +5894,7 @@
                 <a:spcPts val="800"/>
               </a:spcAft>
               <a:defRPr sz="1500">
-                <a:latin typeface="Microsoft YaHei"/>
+                <a:latin typeface="微软雅黑" panose="020B0503020204020204" charset="-122"/>
               </a:defRPr>
             </a:pPr>
             <a:r>
@@ -5488,7 +5907,7 @@
                 <a:spcPts val="800"/>
               </a:spcAft>
               <a:defRPr sz="1500">
-                <a:latin typeface="Microsoft YaHei"/>
+                <a:latin typeface="微软雅黑" panose="020B0503020204020204" charset="-122"/>
               </a:defRPr>
             </a:pPr>
             <a:r>
@@ -5501,12 +5920,300 @@
                 <a:spcPts val="800"/>
               </a:spcAft>
               <a:defRPr sz="1500">
-                <a:latin typeface="Microsoft YaHei"/>
+                <a:latin typeface="微软雅黑" panose="020B0503020204020204" charset="-122"/>
               </a:defRPr>
             </a:pPr>
             <a:r>
               <a:t>测试集波动不替代验证集选模</a:t>
             </a:r>
+          </a:p>
+        </p:txBody>
+      </p:sp>
+    </p:spTree>
+  </p:cSld>
+  <p:clrMapOvr>
+    <a:masterClrMapping/>
+  </p:clrMapOvr>
+</p:sld>
+</file>
+
+<file path=ppt/slides/slide9.xml><?xml version="1.0" encoding="utf-8"?>
+<p:sld xmlns:a="http://schemas.openxmlformats.org/drawingml/2006/main" xmlns:r="http://schemas.openxmlformats.org/officeDocument/2006/relationships" xmlns:p="http://schemas.openxmlformats.org/presentationml/2006/main">
+  <p:cSld>
+    <p:bg>
+      <p:bgPr>
+        <a:solidFill>
+          <a:srgbClr val="F8F7F4"/>
+        </a:solidFill>
+        <a:effectLst/>
+      </p:bgPr>
+    </p:bg>
+    <p:spTree>
+      <p:nvGrpSpPr>
+        <p:cNvPr id="1" name=""/>
+        <p:cNvGrpSpPr/>
+        <p:nvPr/>
+      </p:nvGrpSpPr>
+      <p:grpSpPr/>
+      <p:sp>
+        <p:nvSpPr>
+          <p:cNvPr id="2" name="TextBox 1"/>
+          <p:cNvSpPr txBox="1"/>
+          <p:nvPr/>
+        </p:nvSpPr>
+        <p:spPr>
+          <a:xfrm>
+            <a:off x="502920" y="256032"/>
+            <a:ext cx="2286000" cy="237744"/>
+          </a:xfrm>
+          <a:prstGeom prst="rect">
+            <a:avLst/>
+          </a:prstGeom>
+          <a:noFill/>
+        </p:spPr>
+        <p:txBody>
+          <a:bodyPr wrap="none">
+            <a:spAutoFit/>
+          </a:bodyPr>
+          <a:lstStyle/>
+          <a:p>
+            <a:r>
+              <a:rPr sz="900" b="1">
+                <a:solidFill>
+                  <a:srgbClr val="5F6F82"/>
+                </a:solidFill>
+                <a:latin typeface="微软雅黑" panose="020B0503020204020204" charset="-122"/>
+              </a:rPr>
+              <a:t>DIAGNOSTICS</a:t>
+            </a:r>
+            <a:endParaRPr sz="900" b="1">
+              <a:solidFill>
+                <a:srgbClr val="5F6F82"/>
+              </a:solidFill>
+              <a:latin typeface="微软雅黑" panose="020B0503020204020204" charset="-122"/>
+            </a:endParaRPr>
+          </a:p>
+        </p:txBody>
+      </p:sp>
+      <p:sp>
+        <p:nvSpPr>
+          <p:cNvPr id="3" name="TextBox 2"/>
+          <p:cNvSpPr txBox="1"/>
+          <p:nvPr/>
+        </p:nvSpPr>
+        <p:spPr>
+          <a:xfrm>
+            <a:off x="502920" y="502920"/>
+            <a:ext cx="10424160" cy="502920"/>
+          </a:xfrm>
+          <a:prstGeom prst="rect">
+            <a:avLst/>
+          </a:prstGeom>
+          <a:noFill/>
+        </p:spPr>
+        <p:txBody>
+          <a:bodyPr wrap="none">
+            <a:spAutoFit/>
+          </a:bodyPr>
+          <a:lstStyle/>
+          <a:p>
+            <a:r>
+              <a:rPr sz="2400" b="1">
+                <a:solidFill>
+                  <a:srgbClr val="1E2328"/>
+                </a:solidFill>
+                <a:latin typeface="微软雅黑" panose="020B0503020204020204" charset="-122"/>
+              </a:rPr>
+              <a:t>诊断图：loss 下降与类别混淆</a:t>
+            </a:r>
+            <a:endParaRPr sz="2400" b="1">
+              <a:solidFill>
+                <a:srgbClr val="1E2328"/>
+              </a:solidFill>
+              <a:latin typeface="微软雅黑" panose="020B0503020204020204" charset="-122"/>
+            </a:endParaRPr>
+          </a:p>
+        </p:txBody>
+      </p:sp>
+      <p:pic>
+        <p:nvPicPr>
+          <p:cNvPr id="4" name="Picture 3" descr="two_layer_loss_curve.png"/>
+          <p:cNvPicPr>
+            <a:picLocks noChangeAspect="1"/>
+          </p:cNvPicPr>
+          <p:nvPr/>
+        </p:nvPicPr>
+        <p:blipFill>
+          <a:blip r:embed="rId1"/>
+          <a:srcRect t="7168" r="-732"/>
+          <a:stretch>
+            <a:fillRect/>
+          </a:stretch>
+        </p:blipFill>
+        <p:spPr>
+          <a:xfrm>
+            <a:off x="685800" y="1219200"/>
+            <a:ext cx="5242560" cy="2804160"/>
+          </a:xfrm>
+          <a:prstGeom prst="rect">
+            <a:avLst/>
+          </a:prstGeom>
+        </p:spPr>
+      </p:pic>
+      <p:pic>
+        <p:nvPicPr>
+          <p:cNvPr id="5" name="Picture 4" descr="confusion_matrix_best_model.png"/>
+          <p:cNvPicPr>
+            <a:picLocks noChangeAspect="1"/>
+          </p:cNvPicPr>
+          <p:nvPr/>
+        </p:nvPicPr>
+        <p:blipFill>
+          <a:blip r:embed="rId2"/>
+          <a:srcRect t="6147" r="-1768"/>
+          <a:stretch>
+            <a:fillRect/>
+          </a:stretch>
+        </p:blipFill>
+        <p:spPr>
+          <a:xfrm>
+            <a:off x="6126480" y="1178560"/>
+            <a:ext cx="5118100" cy="4033520"/>
+          </a:xfrm>
+          <a:prstGeom prst="rect">
+            <a:avLst/>
+          </a:prstGeom>
+        </p:spPr>
+      </p:pic>
+      <p:sp>
+        <p:nvSpPr>
+          <p:cNvPr id="6" name="文本框 5"/>
+          <p:cNvSpPr txBox="1"/>
+          <p:nvPr/>
+        </p:nvSpPr>
+        <p:spPr>
+          <a:xfrm>
+            <a:off x="685800" y="4115435"/>
+            <a:ext cx="4064000" cy="368300"/>
+          </a:xfrm>
+          <a:prstGeom prst="rect">
+            <a:avLst/>
+          </a:prstGeom>
+          <a:noFill/>
+        </p:spPr>
+        <p:txBody>
+          <a:bodyPr wrap="square" rtlCol="0">
+            <a:spAutoFit/>
+          </a:bodyPr>
+          <a:p>
+            <a:r>
+              <a:rPr b="1">
+                <a:solidFill>
+                  <a:srgbClr val="1E2328"/>
+                </a:solidFill>
+                <a:latin typeface="微软雅黑" panose="020B0503020204020204" charset="-122"/>
+                <a:sym typeface="+mn-ea"/>
+              </a:rPr>
+              <a:t>TwoLayerNet</a:t>
+            </a:r>
+            <a:r>
+              <a:rPr lang="en-US" b="1">
+                <a:solidFill>
+                  <a:srgbClr val="1E2328"/>
+                </a:solidFill>
+                <a:latin typeface="微软雅黑" panose="020B0503020204020204" charset="-122"/>
+                <a:sym typeface="+mn-ea"/>
+              </a:rPr>
+              <a:t>-N49000 loss</a:t>
+            </a:r>
+            <a:r>
+              <a:rPr lang="zh-CN" altLang="en-US" b="1">
+                <a:solidFill>
+                  <a:srgbClr val="1E2328"/>
+                </a:solidFill>
+                <a:latin typeface="微软雅黑" panose="020B0503020204020204" charset="-122"/>
+                <a:sym typeface="+mn-ea"/>
+              </a:rPr>
+              <a:t>变化</a:t>
+            </a:r>
+            <a:endParaRPr lang="zh-CN" altLang="en-US" b="1">
+              <a:solidFill>
+                <a:srgbClr val="1E2328"/>
+              </a:solidFill>
+              <a:latin typeface="微软雅黑" panose="020B0503020204020204" charset="-122"/>
+              <a:sym typeface="+mn-ea"/>
+            </a:endParaRPr>
+          </a:p>
+        </p:txBody>
+      </p:sp>
+      <p:sp>
+        <p:nvSpPr>
+          <p:cNvPr id="7" name="文本框 6"/>
+          <p:cNvSpPr txBox="1"/>
+          <p:nvPr/>
+        </p:nvSpPr>
+        <p:spPr>
+          <a:xfrm>
+            <a:off x="6193155" y="5394325"/>
+            <a:ext cx="4064000" cy="368300"/>
+          </a:xfrm>
+          <a:prstGeom prst="rect">
+            <a:avLst/>
+          </a:prstGeom>
+          <a:noFill/>
+        </p:spPr>
+        <p:txBody>
+          <a:bodyPr wrap="square" rtlCol="0">
+            <a:spAutoFit/>
+          </a:bodyPr>
+          <a:p>
+            <a:r>
+              <a:rPr b="1">
+                <a:solidFill>
+                  <a:srgbClr val="1E2328"/>
+                </a:solidFill>
+                <a:latin typeface="微软雅黑" panose="020B0503020204020204" charset="-122"/>
+                <a:sym typeface="+mn-ea"/>
+              </a:rPr>
+              <a:t>TwoLayerNet</a:t>
+            </a:r>
+            <a:r>
+              <a:rPr lang="en-US" b="1">
+                <a:solidFill>
+                  <a:srgbClr val="1E2328"/>
+                </a:solidFill>
+                <a:latin typeface="微软雅黑" panose="020B0503020204020204" charset="-122"/>
+                <a:sym typeface="+mn-ea"/>
+              </a:rPr>
+              <a:t>-1000 </a:t>
+            </a:r>
+            <a:r>
+              <a:rPr lang="zh-CN" altLang="en-US" b="1">
+                <a:solidFill>
+                  <a:srgbClr val="1E2328"/>
+                </a:solidFill>
+                <a:latin typeface="微软雅黑" panose="020B0503020204020204" charset="-122"/>
+                <a:sym typeface="+mn-ea"/>
+              </a:rPr>
+              <a:t>混淆</a:t>
+            </a:r>
+            <a:r>
+              <a:rPr lang="zh-CN" altLang="en-US" b="1">
+                <a:solidFill>
+                  <a:srgbClr val="1E2328"/>
+                </a:solidFill>
+                <a:latin typeface="微软雅黑" panose="020B0503020204020204" charset="-122"/>
+                <a:sym typeface="+mn-ea"/>
+              </a:rPr>
+              <a:t>矩阵</a:t>
+            </a:r>
+            <a:endParaRPr lang="zh-CN" altLang="en-US" b="1">
+              <a:solidFill>
+                <a:srgbClr val="1E2328"/>
+              </a:solidFill>
+              <a:latin typeface="微软雅黑" panose="020B0503020204020204" charset="-122"/>
+              <a:sym typeface="+mn-ea"/>
+            </a:endParaRPr>
           </a:p>
         </p:txBody>
       </p:sp>
@@ -5834,6 +6541,10 @@
       </a:style>
     </a:lnDef>
   </a:objectDefaults>
-  <a:extraClrSchemeLst/>
+  <a:extLst>
+    <a:ext uri="{05A4C25C-085E-4340-85A3-A5531E510DB2}">
+      <thm15:themeFamily xmlns:thm15="http://schemas.microsoft.com/office/thememl/2012/main" name="Office Theme" id="{62F939B6-93AF-4DB8-9C6B-D6C7DFDC589F}" vid="{4A3C46E8-61CC-4603-A589-7422A47A8E4A}"/>
+    </a:ext>
+  </a:extLst>
 </a:theme>
 </file>
</xml_diff>